<commit_message>
docs: add 1-click download button and PPTX element entrance animations
</commit_message>
<xml_diff>
--- a/docs/Cloud_Next_27_Agents_CLI_LangGraph.pptx
+++ b/docs/Cloud_Next_27_Agents_CLI_LangGraph.pptx
@@ -385,6 +385,212 @@
   <p:transition spd="med">
     <p:fade/>
   </p:transition>
+  <p:timing>
+    <p:tnLst>
+      <p:par>
+        <p:cTn id="1" dur="indefinite" restart="never" nodeType="tmRoot">
+          <p:childTnLst>
+            <p:seq concurrent="1" nextAc="seek">
+              <p:cTn id="2" dur="indefinite" nodeType="mainSeq">
+                <p:childTnLst>
+                  <p:par>
+                    <p:cTn id="3" fill="hold">
+                      <p:stCondLst>
+                        <p:cond delay="0"/>
+                      </p:stCondLst>
+                      <p:childTnLst>
+                        <p:par>
+                          <p:cTn id="4" presetID="10" presetClass="entr" presetSubtype="0" fill="hold" nodeType="withEffect">
+                            <p:stCondLst>
+                              <p:cond delay="0"/>
+                            </p:stCondLst>
+                            <p:childTnLst>
+                              <p:set>
+                                <p:cBhvr>
+                                  <p:cTn id="5" dur="1" fill="hold">
+                                    <p:stCondLst>
+                                      <p:cond delay="0"/>
+                                    </p:stCondLst>
+                                  </p:cTn>
+                                  <p:tgtEl>
+                                    <p:spTgt spid="6"/>
+                                  </p:tgtEl>
+                                  <p:attrNameLst>
+                                    <p:attrName>style.visibility</p:attrName>
+                                  </p:attrNameLst>
+                                </p:cBhvr>
+                                <p:to>
+                                  <p:strVal val="visible"/>
+                                </p:to>
+                              </p:set>
+                              <p:animEffect transition="in" filter="fade">
+                                <p:cBhvr>
+                                  <p:cTn id="6" dur="450"/>
+                                  <p:tgtEl>
+                                    <p:spTgt spid="6"/>
+                                  </p:tgtEl>
+                                </p:cBhvr>
+                              </p:animEffect>
+                            </p:childTnLst>
+                          </p:cTn>
+                        </p:par>
+                      </p:childTnLst>
+                    </p:cTn>
+                  </p:par>
+                  <p:par>
+                    <p:cTn id="7" fill="hold">
+                      <p:stCondLst>
+                        <p:cond delay="180"/>
+                      </p:stCondLst>
+                      <p:childTnLst>
+                        <p:par>
+                          <p:cTn id="8" presetID="10" presetClass="entr" presetSubtype="0" fill="hold" nodeType="withEffect">
+                            <p:stCondLst>
+                              <p:cond delay="0"/>
+                            </p:stCondLst>
+                            <p:childTnLst>
+                              <p:set>
+                                <p:cBhvr>
+                                  <p:cTn id="9" dur="1" fill="hold">
+                                    <p:stCondLst>
+                                      <p:cond delay="0"/>
+                                    </p:stCondLst>
+                                  </p:cTn>
+                                  <p:tgtEl>
+                                    <p:spTgt spid="7"/>
+                                  </p:tgtEl>
+                                  <p:attrNameLst>
+                                    <p:attrName>style.visibility</p:attrName>
+                                  </p:attrNameLst>
+                                </p:cBhvr>
+                                <p:to>
+                                  <p:strVal val="visible"/>
+                                </p:to>
+                              </p:set>
+                              <p:animEffect transition="in" filter="fade">
+                                <p:cBhvr>
+                                  <p:cTn id="10" dur="450"/>
+                                  <p:tgtEl>
+                                    <p:spTgt spid="7"/>
+                                  </p:tgtEl>
+                                </p:cBhvr>
+                              </p:animEffect>
+                            </p:childTnLst>
+                          </p:cTn>
+                        </p:par>
+                      </p:childTnLst>
+                    </p:cTn>
+                  </p:par>
+                  <p:par>
+                    <p:cTn id="11" fill="hold">
+                      <p:stCondLst>
+                        <p:cond delay="360"/>
+                      </p:stCondLst>
+                      <p:childTnLst>
+                        <p:par>
+                          <p:cTn id="12" presetID="10" presetClass="entr" presetSubtype="0" fill="hold" nodeType="withEffect">
+                            <p:stCondLst>
+                              <p:cond delay="0"/>
+                            </p:stCondLst>
+                            <p:childTnLst>
+                              <p:set>
+                                <p:cBhvr>
+                                  <p:cTn id="13" dur="1" fill="hold">
+                                    <p:stCondLst>
+                                      <p:cond delay="0"/>
+                                    </p:stCondLst>
+                                  </p:cTn>
+                                  <p:tgtEl>
+                                    <p:spTgt spid="8"/>
+                                  </p:tgtEl>
+                                  <p:attrNameLst>
+                                    <p:attrName>style.visibility</p:attrName>
+                                  </p:attrNameLst>
+                                </p:cBhvr>
+                                <p:to>
+                                  <p:strVal val="visible"/>
+                                </p:to>
+                              </p:set>
+                              <p:animEffect transition="in" filter="fade">
+                                <p:cBhvr>
+                                  <p:cTn id="14" dur="450"/>
+                                  <p:tgtEl>
+                                    <p:spTgt spid="8"/>
+                                  </p:tgtEl>
+                                </p:cBhvr>
+                              </p:animEffect>
+                            </p:childTnLst>
+                          </p:cTn>
+                        </p:par>
+                      </p:childTnLst>
+                    </p:cTn>
+                  </p:par>
+                  <p:par>
+                    <p:cTn id="15" fill="hold">
+                      <p:stCondLst>
+                        <p:cond delay="540"/>
+                      </p:stCondLst>
+                      <p:childTnLst>
+                        <p:par>
+                          <p:cTn id="16" presetID="10" presetClass="entr" presetSubtype="0" fill="hold" nodeType="withEffect">
+                            <p:stCondLst>
+                              <p:cond delay="0"/>
+                            </p:stCondLst>
+                            <p:childTnLst>
+                              <p:set>
+                                <p:cBhvr>
+                                  <p:cTn id="17" dur="1" fill="hold">
+                                    <p:stCondLst>
+                                      <p:cond delay="0"/>
+                                    </p:stCondLst>
+                                  </p:cTn>
+                                  <p:tgtEl>
+                                    <p:spTgt spid="9"/>
+                                  </p:tgtEl>
+                                  <p:attrNameLst>
+                                    <p:attrName>style.visibility</p:attrName>
+                                  </p:attrNameLst>
+                                </p:cBhvr>
+                                <p:to>
+                                  <p:strVal val="visible"/>
+                                </p:to>
+                              </p:set>
+                              <p:animEffect transition="in" filter="fade">
+                                <p:cBhvr>
+                                  <p:cTn id="18" dur="450"/>
+                                  <p:tgtEl>
+                                    <p:spTgt spid="9"/>
+                                  </p:tgtEl>
+                                </p:cBhvr>
+                              </p:animEffect>
+                            </p:childTnLst>
+                          </p:cTn>
+                        </p:par>
+                      </p:childTnLst>
+                    </p:cTn>
+                  </p:par>
+                </p:childTnLst>
+              </p:cTn>
+              <p:prevCondLst>
+                <p:cond evt="onPrev" delay="0">
+                  <p:tgtEl>
+                    <p:sldTgt/>
+                  </p:tgtEl>
+                </p:cond>
+              </p:prevCondLst>
+              <p:nextCondLst>
+                <p:cond evt="onNext" delay="0">
+                  <p:tgtEl>
+                    <p:sldTgt/>
+                  </p:tgtEl>
+                </p:cond>
+              </p:nextCondLst>
+            </p:seq>
+          </p:childTnLst>
+        </p:cTn>
+      </p:par>
+    </p:tnLst>
+  </p:timing>
 </p:sld>
 </file>
 
@@ -1261,6 +1467,476 @@
   <p:transition spd="med">
     <p:fade/>
   </p:transition>
+  <p:timing>
+    <p:tnLst>
+      <p:par>
+        <p:cTn id="1" dur="indefinite" restart="never" nodeType="tmRoot">
+          <p:childTnLst>
+            <p:seq concurrent="1" nextAc="seek">
+              <p:cTn id="2" dur="indefinite" nodeType="mainSeq">
+                <p:childTnLst>
+                  <p:par>
+                    <p:cTn id="3" fill="hold">
+                      <p:stCondLst>
+                        <p:cond delay="0"/>
+                      </p:stCondLst>
+                      <p:childTnLst>
+                        <p:par>
+                          <p:cTn id="4" presetID="10" presetClass="entr" presetSubtype="0" fill="hold" nodeType="withEffect">
+                            <p:stCondLst>
+                              <p:cond delay="0"/>
+                            </p:stCondLst>
+                            <p:childTnLst>
+                              <p:set>
+                                <p:cBhvr>
+                                  <p:cTn id="5" dur="1" fill="hold">
+                                    <p:stCondLst>
+                                      <p:cond delay="0"/>
+                                    </p:stCondLst>
+                                  </p:cTn>
+                                  <p:tgtEl>
+                                    <p:spTgt spid="6"/>
+                                  </p:tgtEl>
+                                  <p:attrNameLst>
+                                    <p:attrName>style.visibility</p:attrName>
+                                  </p:attrNameLst>
+                                </p:cBhvr>
+                                <p:to>
+                                  <p:strVal val="visible"/>
+                                </p:to>
+                              </p:set>
+                              <p:animEffect transition="in" filter="fade">
+                                <p:cBhvr>
+                                  <p:cTn id="6" dur="450"/>
+                                  <p:tgtEl>
+                                    <p:spTgt spid="6"/>
+                                  </p:tgtEl>
+                                </p:cBhvr>
+                              </p:animEffect>
+                            </p:childTnLst>
+                          </p:cTn>
+                        </p:par>
+                      </p:childTnLst>
+                    </p:cTn>
+                  </p:par>
+                  <p:par>
+                    <p:cTn id="7" fill="hold">
+                      <p:stCondLst>
+                        <p:cond delay="180"/>
+                      </p:stCondLst>
+                      <p:childTnLst>
+                        <p:par>
+                          <p:cTn id="8" presetID="10" presetClass="entr" presetSubtype="0" fill="hold" nodeType="withEffect">
+                            <p:stCondLst>
+                              <p:cond delay="0"/>
+                            </p:stCondLst>
+                            <p:childTnLst>
+                              <p:set>
+                                <p:cBhvr>
+                                  <p:cTn id="9" dur="1" fill="hold">
+                                    <p:stCondLst>
+                                      <p:cond delay="0"/>
+                                    </p:stCondLst>
+                                  </p:cTn>
+                                  <p:tgtEl>
+                                    <p:spTgt spid="7"/>
+                                  </p:tgtEl>
+                                  <p:attrNameLst>
+                                    <p:attrName>style.visibility</p:attrName>
+                                  </p:attrNameLst>
+                                </p:cBhvr>
+                                <p:to>
+                                  <p:strVal val="visible"/>
+                                </p:to>
+                              </p:set>
+                              <p:animEffect transition="in" filter="fade">
+                                <p:cBhvr>
+                                  <p:cTn id="10" dur="450"/>
+                                  <p:tgtEl>
+                                    <p:spTgt spid="7"/>
+                                  </p:tgtEl>
+                                </p:cBhvr>
+                              </p:animEffect>
+                            </p:childTnLst>
+                          </p:cTn>
+                        </p:par>
+                      </p:childTnLst>
+                    </p:cTn>
+                  </p:par>
+                  <p:par>
+                    <p:cTn id="11" fill="hold">
+                      <p:stCondLst>
+                        <p:cond delay="360"/>
+                      </p:stCondLst>
+                      <p:childTnLst>
+                        <p:par>
+                          <p:cTn id="12" presetID="10" presetClass="entr" presetSubtype="0" fill="hold" nodeType="withEffect">
+                            <p:stCondLst>
+                              <p:cond delay="0"/>
+                            </p:stCondLst>
+                            <p:childTnLst>
+                              <p:set>
+                                <p:cBhvr>
+                                  <p:cTn id="13" dur="1" fill="hold">
+                                    <p:stCondLst>
+                                      <p:cond delay="0"/>
+                                    </p:stCondLst>
+                                  </p:cTn>
+                                  <p:tgtEl>
+                                    <p:spTgt spid="8"/>
+                                  </p:tgtEl>
+                                  <p:attrNameLst>
+                                    <p:attrName>style.visibility</p:attrName>
+                                  </p:attrNameLst>
+                                </p:cBhvr>
+                                <p:to>
+                                  <p:strVal val="visible"/>
+                                </p:to>
+                              </p:set>
+                              <p:animEffect transition="in" filter="fade">
+                                <p:cBhvr>
+                                  <p:cTn id="14" dur="450"/>
+                                  <p:tgtEl>
+                                    <p:spTgt spid="8"/>
+                                  </p:tgtEl>
+                                </p:cBhvr>
+                              </p:animEffect>
+                            </p:childTnLst>
+                          </p:cTn>
+                        </p:par>
+                      </p:childTnLst>
+                    </p:cTn>
+                  </p:par>
+                  <p:par>
+                    <p:cTn id="15" fill="hold">
+                      <p:stCondLst>
+                        <p:cond delay="540"/>
+                      </p:stCondLst>
+                      <p:childTnLst>
+                        <p:par>
+                          <p:cTn id="16" presetID="10" presetClass="entr" presetSubtype="0" fill="hold" nodeType="withEffect">
+                            <p:stCondLst>
+                              <p:cond delay="0"/>
+                            </p:stCondLst>
+                            <p:childTnLst>
+                              <p:set>
+                                <p:cBhvr>
+                                  <p:cTn id="17" dur="1" fill="hold">
+                                    <p:stCondLst>
+                                      <p:cond delay="0"/>
+                                    </p:stCondLst>
+                                  </p:cTn>
+                                  <p:tgtEl>
+                                    <p:spTgt spid="9"/>
+                                  </p:tgtEl>
+                                  <p:attrNameLst>
+                                    <p:attrName>style.visibility</p:attrName>
+                                  </p:attrNameLst>
+                                </p:cBhvr>
+                                <p:to>
+                                  <p:strVal val="visible"/>
+                                </p:to>
+                              </p:set>
+                              <p:animEffect transition="in" filter="fade">
+                                <p:cBhvr>
+                                  <p:cTn id="18" dur="450"/>
+                                  <p:tgtEl>
+                                    <p:spTgt spid="9"/>
+                                  </p:tgtEl>
+                                </p:cBhvr>
+                              </p:animEffect>
+                            </p:childTnLst>
+                          </p:cTn>
+                        </p:par>
+                      </p:childTnLst>
+                    </p:cTn>
+                  </p:par>
+                  <p:par>
+                    <p:cTn id="19" fill="hold">
+                      <p:stCondLst>
+                        <p:cond delay="720"/>
+                      </p:stCondLst>
+                      <p:childTnLst>
+                        <p:par>
+                          <p:cTn id="20" presetID="10" presetClass="entr" presetSubtype="0" fill="hold" nodeType="withEffect">
+                            <p:stCondLst>
+                              <p:cond delay="0"/>
+                            </p:stCondLst>
+                            <p:childTnLst>
+                              <p:set>
+                                <p:cBhvr>
+                                  <p:cTn id="21" dur="1" fill="hold">
+                                    <p:stCondLst>
+                                      <p:cond delay="0"/>
+                                    </p:stCondLst>
+                                  </p:cTn>
+                                  <p:tgtEl>
+                                    <p:spTgt spid="10"/>
+                                  </p:tgtEl>
+                                  <p:attrNameLst>
+                                    <p:attrName>style.visibility</p:attrName>
+                                  </p:attrNameLst>
+                                </p:cBhvr>
+                                <p:to>
+                                  <p:strVal val="visible"/>
+                                </p:to>
+                              </p:set>
+                              <p:animEffect transition="in" filter="fade">
+                                <p:cBhvr>
+                                  <p:cTn id="22" dur="450"/>
+                                  <p:tgtEl>
+                                    <p:spTgt spid="10"/>
+                                  </p:tgtEl>
+                                </p:cBhvr>
+                              </p:animEffect>
+                            </p:childTnLst>
+                          </p:cTn>
+                        </p:par>
+                      </p:childTnLst>
+                    </p:cTn>
+                  </p:par>
+                  <p:par>
+                    <p:cTn id="23" fill="hold">
+                      <p:stCondLst>
+                        <p:cond delay="900"/>
+                      </p:stCondLst>
+                      <p:childTnLst>
+                        <p:par>
+                          <p:cTn id="24" presetID="10" presetClass="entr" presetSubtype="0" fill="hold" nodeType="withEffect">
+                            <p:stCondLst>
+                              <p:cond delay="0"/>
+                            </p:stCondLst>
+                            <p:childTnLst>
+                              <p:set>
+                                <p:cBhvr>
+                                  <p:cTn id="25" dur="1" fill="hold">
+                                    <p:stCondLst>
+                                      <p:cond delay="0"/>
+                                    </p:stCondLst>
+                                  </p:cTn>
+                                  <p:tgtEl>
+                                    <p:spTgt spid="11"/>
+                                  </p:tgtEl>
+                                  <p:attrNameLst>
+                                    <p:attrName>style.visibility</p:attrName>
+                                  </p:attrNameLst>
+                                </p:cBhvr>
+                                <p:to>
+                                  <p:strVal val="visible"/>
+                                </p:to>
+                              </p:set>
+                              <p:animEffect transition="in" filter="fade">
+                                <p:cBhvr>
+                                  <p:cTn id="26" dur="450"/>
+                                  <p:tgtEl>
+                                    <p:spTgt spid="11"/>
+                                  </p:tgtEl>
+                                </p:cBhvr>
+                              </p:animEffect>
+                            </p:childTnLst>
+                          </p:cTn>
+                        </p:par>
+                      </p:childTnLst>
+                    </p:cTn>
+                  </p:par>
+                  <p:par>
+                    <p:cTn id="27" fill="hold">
+                      <p:stCondLst>
+                        <p:cond delay="1080"/>
+                      </p:stCondLst>
+                      <p:childTnLst>
+                        <p:par>
+                          <p:cTn id="28" presetID="10" presetClass="entr" presetSubtype="0" fill="hold" nodeType="withEffect">
+                            <p:stCondLst>
+                              <p:cond delay="0"/>
+                            </p:stCondLst>
+                            <p:childTnLst>
+                              <p:set>
+                                <p:cBhvr>
+                                  <p:cTn id="29" dur="1" fill="hold">
+                                    <p:stCondLst>
+                                      <p:cond delay="0"/>
+                                    </p:stCondLst>
+                                  </p:cTn>
+                                  <p:tgtEl>
+                                    <p:spTgt spid="12"/>
+                                  </p:tgtEl>
+                                  <p:attrNameLst>
+                                    <p:attrName>style.visibility</p:attrName>
+                                  </p:attrNameLst>
+                                </p:cBhvr>
+                                <p:to>
+                                  <p:strVal val="visible"/>
+                                </p:to>
+                              </p:set>
+                              <p:animEffect transition="in" filter="fade">
+                                <p:cBhvr>
+                                  <p:cTn id="30" dur="450"/>
+                                  <p:tgtEl>
+                                    <p:spTgt spid="12"/>
+                                  </p:tgtEl>
+                                </p:cBhvr>
+                              </p:animEffect>
+                            </p:childTnLst>
+                          </p:cTn>
+                        </p:par>
+                      </p:childTnLst>
+                    </p:cTn>
+                  </p:par>
+                  <p:par>
+                    <p:cTn id="31" fill="hold">
+                      <p:stCondLst>
+                        <p:cond delay="1260"/>
+                      </p:stCondLst>
+                      <p:childTnLst>
+                        <p:par>
+                          <p:cTn id="32" presetID="10" presetClass="entr" presetSubtype="0" fill="hold" nodeType="withEffect">
+                            <p:stCondLst>
+                              <p:cond delay="0"/>
+                            </p:stCondLst>
+                            <p:childTnLst>
+                              <p:set>
+                                <p:cBhvr>
+                                  <p:cTn id="33" dur="1" fill="hold">
+                                    <p:stCondLst>
+                                      <p:cond delay="0"/>
+                                    </p:stCondLst>
+                                  </p:cTn>
+                                  <p:tgtEl>
+                                    <p:spTgt spid="13"/>
+                                  </p:tgtEl>
+                                  <p:attrNameLst>
+                                    <p:attrName>style.visibility</p:attrName>
+                                  </p:attrNameLst>
+                                </p:cBhvr>
+                                <p:to>
+                                  <p:strVal val="visible"/>
+                                </p:to>
+                              </p:set>
+                              <p:animEffect transition="in" filter="fade">
+                                <p:cBhvr>
+                                  <p:cTn id="34" dur="450"/>
+                                  <p:tgtEl>
+                                    <p:spTgt spid="13"/>
+                                  </p:tgtEl>
+                                </p:cBhvr>
+                              </p:animEffect>
+                            </p:childTnLst>
+                          </p:cTn>
+                        </p:par>
+                      </p:childTnLst>
+                    </p:cTn>
+                  </p:par>
+                  <p:par>
+                    <p:cTn id="35" fill="hold">
+                      <p:stCondLst>
+                        <p:cond delay="1440"/>
+                      </p:stCondLst>
+                      <p:childTnLst>
+                        <p:par>
+                          <p:cTn id="36" presetID="10" presetClass="entr" presetSubtype="0" fill="hold" nodeType="withEffect">
+                            <p:stCondLst>
+                              <p:cond delay="0"/>
+                            </p:stCondLst>
+                            <p:childTnLst>
+                              <p:set>
+                                <p:cBhvr>
+                                  <p:cTn id="37" dur="1" fill="hold">
+                                    <p:stCondLst>
+                                      <p:cond delay="0"/>
+                                    </p:stCondLst>
+                                  </p:cTn>
+                                  <p:tgtEl>
+                                    <p:spTgt spid="14"/>
+                                  </p:tgtEl>
+                                  <p:attrNameLst>
+                                    <p:attrName>style.visibility</p:attrName>
+                                  </p:attrNameLst>
+                                </p:cBhvr>
+                                <p:to>
+                                  <p:strVal val="visible"/>
+                                </p:to>
+                              </p:set>
+                              <p:animEffect transition="in" filter="fade">
+                                <p:cBhvr>
+                                  <p:cTn id="38" dur="450"/>
+                                  <p:tgtEl>
+                                    <p:spTgt spid="14"/>
+                                  </p:tgtEl>
+                                </p:cBhvr>
+                              </p:animEffect>
+                            </p:childTnLst>
+                          </p:cTn>
+                        </p:par>
+                      </p:childTnLst>
+                    </p:cTn>
+                  </p:par>
+                  <p:par>
+                    <p:cTn id="39" fill="hold">
+                      <p:stCondLst>
+                        <p:cond delay="1620"/>
+                      </p:stCondLst>
+                      <p:childTnLst>
+                        <p:par>
+                          <p:cTn id="40" presetID="10" presetClass="entr" presetSubtype="0" fill="hold" nodeType="withEffect">
+                            <p:stCondLst>
+                              <p:cond delay="0"/>
+                            </p:stCondLst>
+                            <p:childTnLst>
+                              <p:set>
+                                <p:cBhvr>
+                                  <p:cTn id="41" dur="1" fill="hold">
+                                    <p:stCondLst>
+                                      <p:cond delay="0"/>
+                                    </p:stCondLst>
+                                  </p:cTn>
+                                  <p:tgtEl>
+                                    <p:spTgt spid="15"/>
+                                  </p:tgtEl>
+                                  <p:attrNameLst>
+                                    <p:attrName>style.visibility</p:attrName>
+                                  </p:attrNameLst>
+                                </p:cBhvr>
+                                <p:to>
+                                  <p:strVal val="visible"/>
+                                </p:to>
+                              </p:set>
+                              <p:animEffect transition="in" filter="fade">
+                                <p:cBhvr>
+                                  <p:cTn id="42" dur="450"/>
+                                  <p:tgtEl>
+                                    <p:spTgt spid="15"/>
+                                  </p:tgtEl>
+                                </p:cBhvr>
+                              </p:animEffect>
+                            </p:childTnLst>
+                          </p:cTn>
+                        </p:par>
+                      </p:childTnLst>
+                    </p:cTn>
+                  </p:par>
+                </p:childTnLst>
+              </p:cTn>
+              <p:prevCondLst>
+                <p:cond evt="onPrev" delay="0">
+                  <p:tgtEl>
+                    <p:sldTgt/>
+                  </p:tgtEl>
+                </p:cond>
+              </p:prevCondLst>
+              <p:nextCondLst>
+                <p:cond evt="onNext" delay="0">
+                  <p:tgtEl>
+                    <p:sldTgt/>
+                  </p:tgtEl>
+                </p:cond>
+              </p:nextCondLst>
+            </p:seq>
+          </p:childTnLst>
+        </p:cTn>
+      </p:par>
+    </p:tnLst>
+  </p:timing>
 </p:sld>
 </file>
 
@@ -1843,6 +2519,344 @@
   <p:transition spd="med">
     <p:fade/>
   </p:transition>
+  <p:timing>
+    <p:tnLst>
+      <p:par>
+        <p:cTn id="1" dur="indefinite" restart="never" nodeType="tmRoot">
+          <p:childTnLst>
+            <p:seq concurrent="1" nextAc="seek">
+              <p:cTn id="2" dur="indefinite" nodeType="mainSeq">
+                <p:childTnLst>
+                  <p:par>
+                    <p:cTn id="3" fill="hold">
+                      <p:stCondLst>
+                        <p:cond delay="0"/>
+                      </p:stCondLst>
+                      <p:childTnLst>
+                        <p:par>
+                          <p:cTn id="4" presetID="10" presetClass="entr" presetSubtype="0" fill="hold" nodeType="withEffect">
+                            <p:stCondLst>
+                              <p:cond delay="0"/>
+                            </p:stCondLst>
+                            <p:childTnLst>
+                              <p:set>
+                                <p:cBhvr>
+                                  <p:cTn id="5" dur="1" fill="hold">
+                                    <p:stCondLst>
+                                      <p:cond delay="0"/>
+                                    </p:stCondLst>
+                                  </p:cTn>
+                                  <p:tgtEl>
+                                    <p:spTgt spid="6"/>
+                                  </p:tgtEl>
+                                  <p:attrNameLst>
+                                    <p:attrName>style.visibility</p:attrName>
+                                  </p:attrNameLst>
+                                </p:cBhvr>
+                                <p:to>
+                                  <p:strVal val="visible"/>
+                                </p:to>
+                              </p:set>
+                              <p:animEffect transition="in" filter="fade">
+                                <p:cBhvr>
+                                  <p:cTn id="6" dur="450"/>
+                                  <p:tgtEl>
+                                    <p:spTgt spid="6"/>
+                                  </p:tgtEl>
+                                </p:cBhvr>
+                              </p:animEffect>
+                            </p:childTnLst>
+                          </p:cTn>
+                        </p:par>
+                      </p:childTnLst>
+                    </p:cTn>
+                  </p:par>
+                  <p:par>
+                    <p:cTn id="7" fill="hold">
+                      <p:stCondLst>
+                        <p:cond delay="180"/>
+                      </p:stCondLst>
+                      <p:childTnLst>
+                        <p:par>
+                          <p:cTn id="8" presetID="10" presetClass="entr" presetSubtype="0" fill="hold" nodeType="withEffect">
+                            <p:stCondLst>
+                              <p:cond delay="0"/>
+                            </p:stCondLst>
+                            <p:childTnLst>
+                              <p:set>
+                                <p:cBhvr>
+                                  <p:cTn id="9" dur="1" fill="hold">
+                                    <p:stCondLst>
+                                      <p:cond delay="0"/>
+                                    </p:stCondLst>
+                                  </p:cTn>
+                                  <p:tgtEl>
+                                    <p:spTgt spid="7"/>
+                                  </p:tgtEl>
+                                  <p:attrNameLst>
+                                    <p:attrName>style.visibility</p:attrName>
+                                  </p:attrNameLst>
+                                </p:cBhvr>
+                                <p:to>
+                                  <p:strVal val="visible"/>
+                                </p:to>
+                              </p:set>
+                              <p:animEffect transition="in" filter="fade">
+                                <p:cBhvr>
+                                  <p:cTn id="10" dur="450"/>
+                                  <p:tgtEl>
+                                    <p:spTgt spid="7"/>
+                                  </p:tgtEl>
+                                </p:cBhvr>
+                              </p:animEffect>
+                            </p:childTnLst>
+                          </p:cTn>
+                        </p:par>
+                      </p:childTnLst>
+                    </p:cTn>
+                  </p:par>
+                  <p:par>
+                    <p:cTn id="11" fill="hold">
+                      <p:stCondLst>
+                        <p:cond delay="360"/>
+                      </p:stCondLst>
+                      <p:childTnLst>
+                        <p:par>
+                          <p:cTn id="12" presetID="10" presetClass="entr" presetSubtype="0" fill="hold" nodeType="withEffect">
+                            <p:stCondLst>
+                              <p:cond delay="0"/>
+                            </p:stCondLst>
+                            <p:childTnLst>
+                              <p:set>
+                                <p:cBhvr>
+                                  <p:cTn id="13" dur="1" fill="hold">
+                                    <p:stCondLst>
+                                      <p:cond delay="0"/>
+                                    </p:stCondLst>
+                                  </p:cTn>
+                                  <p:tgtEl>
+                                    <p:spTgt spid="8"/>
+                                  </p:tgtEl>
+                                  <p:attrNameLst>
+                                    <p:attrName>style.visibility</p:attrName>
+                                  </p:attrNameLst>
+                                </p:cBhvr>
+                                <p:to>
+                                  <p:strVal val="visible"/>
+                                </p:to>
+                              </p:set>
+                              <p:animEffect transition="in" filter="fade">
+                                <p:cBhvr>
+                                  <p:cTn id="14" dur="450"/>
+                                  <p:tgtEl>
+                                    <p:spTgt spid="8"/>
+                                  </p:tgtEl>
+                                </p:cBhvr>
+                              </p:animEffect>
+                            </p:childTnLst>
+                          </p:cTn>
+                        </p:par>
+                      </p:childTnLst>
+                    </p:cTn>
+                  </p:par>
+                  <p:par>
+                    <p:cTn id="15" fill="hold">
+                      <p:stCondLst>
+                        <p:cond delay="540"/>
+                      </p:stCondLst>
+                      <p:childTnLst>
+                        <p:par>
+                          <p:cTn id="16" presetID="10" presetClass="entr" presetSubtype="0" fill="hold" nodeType="withEffect">
+                            <p:stCondLst>
+                              <p:cond delay="0"/>
+                            </p:stCondLst>
+                            <p:childTnLst>
+                              <p:set>
+                                <p:cBhvr>
+                                  <p:cTn id="17" dur="1" fill="hold">
+                                    <p:stCondLst>
+                                      <p:cond delay="0"/>
+                                    </p:stCondLst>
+                                  </p:cTn>
+                                  <p:tgtEl>
+                                    <p:spTgt spid="9"/>
+                                  </p:tgtEl>
+                                  <p:attrNameLst>
+                                    <p:attrName>style.visibility</p:attrName>
+                                  </p:attrNameLst>
+                                </p:cBhvr>
+                                <p:to>
+                                  <p:strVal val="visible"/>
+                                </p:to>
+                              </p:set>
+                              <p:animEffect transition="in" filter="fade">
+                                <p:cBhvr>
+                                  <p:cTn id="18" dur="450"/>
+                                  <p:tgtEl>
+                                    <p:spTgt spid="9"/>
+                                  </p:tgtEl>
+                                </p:cBhvr>
+                              </p:animEffect>
+                            </p:childTnLst>
+                          </p:cTn>
+                        </p:par>
+                      </p:childTnLst>
+                    </p:cTn>
+                  </p:par>
+                  <p:par>
+                    <p:cTn id="19" fill="hold">
+                      <p:stCondLst>
+                        <p:cond delay="720"/>
+                      </p:stCondLst>
+                      <p:childTnLst>
+                        <p:par>
+                          <p:cTn id="20" presetID="10" presetClass="entr" presetSubtype="0" fill="hold" nodeType="withEffect">
+                            <p:stCondLst>
+                              <p:cond delay="0"/>
+                            </p:stCondLst>
+                            <p:childTnLst>
+                              <p:set>
+                                <p:cBhvr>
+                                  <p:cTn id="21" dur="1" fill="hold">
+                                    <p:stCondLst>
+                                      <p:cond delay="0"/>
+                                    </p:stCondLst>
+                                  </p:cTn>
+                                  <p:tgtEl>
+                                    <p:spTgt spid="10"/>
+                                  </p:tgtEl>
+                                  <p:attrNameLst>
+                                    <p:attrName>style.visibility</p:attrName>
+                                  </p:attrNameLst>
+                                </p:cBhvr>
+                                <p:to>
+                                  <p:strVal val="visible"/>
+                                </p:to>
+                              </p:set>
+                              <p:animEffect transition="in" filter="fade">
+                                <p:cBhvr>
+                                  <p:cTn id="22" dur="450"/>
+                                  <p:tgtEl>
+                                    <p:spTgt spid="10"/>
+                                  </p:tgtEl>
+                                </p:cBhvr>
+                              </p:animEffect>
+                            </p:childTnLst>
+                          </p:cTn>
+                        </p:par>
+                      </p:childTnLst>
+                    </p:cTn>
+                  </p:par>
+                  <p:par>
+                    <p:cTn id="23" fill="hold">
+                      <p:stCondLst>
+                        <p:cond delay="900"/>
+                      </p:stCondLst>
+                      <p:childTnLst>
+                        <p:par>
+                          <p:cTn id="24" presetID="10" presetClass="entr" presetSubtype="0" fill="hold" nodeType="withEffect">
+                            <p:stCondLst>
+                              <p:cond delay="0"/>
+                            </p:stCondLst>
+                            <p:childTnLst>
+                              <p:set>
+                                <p:cBhvr>
+                                  <p:cTn id="25" dur="1" fill="hold">
+                                    <p:stCondLst>
+                                      <p:cond delay="0"/>
+                                    </p:stCondLst>
+                                  </p:cTn>
+                                  <p:tgtEl>
+                                    <p:spTgt spid="11"/>
+                                  </p:tgtEl>
+                                  <p:attrNameLst>
+                                    <p:attrName>style.visibility</p:attrName>
+                                  </p:attrNameLst>
+                                </p:cBhvr>
+                                <p:to>
+                                  <p:strVal val="visible"/>
+                                </p:to>
+                              </p:set>
+                              <p:animEffect transition="in" filter="fade">
+                                <p:cBhvr>
+                                  <p:cTn id="26" dur="450"/>
+                                  <p:tgtEl>
+                                    <p:spTgt spid="11"/>
+                                  </p:tgtEl>
+                                </p:cBhvr>
+                              </p:animEffect>
+                            </p:childTnLst>
+                          </p:cTn>
+                        </p:par>
+                      </p:childTnLst>
+                    </p:cTn>
+                  </p:par>
+                  <p:par>
+                    <p:cTn id="27" fill="hold">
+                      <p:stCondLst>
+                        <p:cond delay="1080"/>
+                      </p:stCondLst>
+                      <p:childTnLst>
+                        <p:par>
+                          <p:cTn id="28" presetID="10" presetClass="entr" presetSubtype="0" fill="hold" nodeType="withEffect">
+                            <p:stCondLst>
+                              <p:cond delay="0"/>
+                            </p:stCondLst>
+                            <p:childTnLst>
+                              <p:set>
+                                <p:cBhvr>
+                                  <p:cTn id="29" dur="1" fill="hold">
+                                    <p:stCondLst>
+                                      <p:cond delay="0"/>
+                                    </p:stCondLst>
+                                  </p:cTn>
+                                  <p:tgtEl>
+                                    <p:spTgt spid="12"/>
+                                  </p:tgtEl>
+                                  <p:attrNameLst>
+                                    <p:attrName>style.visibility</p:attrName>
+                                  </p:attrNameLst>
+                                </p:cBhvr>
+                                <p:to>
+                                  <p:strVal val="visible"/>
+                                </p:to>
+                              </p:set>
+                              <p:animEffect transition="in" filter="fade">
+                                <p:cBhvr>
+                                  <p:cTn id="30" dur="450"/>
+                                  <p:tgtEl>
+                                    <p:spTgt spid="12"/>
+                                  </p:tgtEl>
+                                </p:cBhvr>
+                              </p:animEffect>
+                            </p:childTnLst>
+                          </p:cTn>
+                        </p:par>
+                      </p:childTnLst>
+                    </p:cTn>
+                  </p:par>
+                </p:childTnLst>
+              </p:cTn>
+              <p:prevCondLst>
+                <p:cond evt="onPrev" delay="0">
+                  <p:tgtEl>
+                    <p:sldTgt/>
+                  </p:tgtEl>
+                </p:cond>
+              </p:prevCondLst>
+              <p:nextCondLst>
+                <p:cond evt="onNext" delay="0">
+                  <p:tgtEl>
+                    <p:sldTgt/>
+                  </p:tgtEl>
+                </p:cond>
+              </p:nextCondLst>
+            </p:seq>
+          </p:childTnLst>
+        </p:cTn>
+      </p:par>
+    </p:tnLst>
+  </p:timing>
 </p:sld>
 </file>
 
@@ -2527,6 +3541,344 @@
   <p:transition spd="med">
     <p:fade/>
   </p:transition>
+  <p:timing>
+    <p:tnLst>
+      <p:par>
+        <p:cTn id="1" dur="indefinite" restart="never" nodeType="tmRoot">
+          <p:childTnLst>
+            <p:seq concurrent="1" nextAc="seek">
+              <p:cTn id="2" dur="indefinite" nodeType="mainSeq">
+                <p:childTnLst>
+                  <p:par>
+                    <p:cTn id="3" fill="hold">
+                      <p:stCondLst>
+                        <p:cond delay="0"/>
+                      </p:stCondLst>
+                      <p:childTnLst>
+                        <p:par>
+                          <p:cTn id="4" presetID="10" presetClass="entr" presetSubtype="0" fill="hold" nodeType="withEffect">
+                            <p:stCondLst>
+                              <p:cond delay="0"/>
+                            </p:stCondLst>
+                            <p:childTnLst>
+                              <p:set>
+                                <p:cBhvr>
+                                  <p:cTn id="5" dur="1" fill="hold">
+                                    <p:stCondLst>
+                                      <p:cond delay="0"/>
+                                    </p:stCondLst>
+                                  </p:cTn>
+                                  <p:tgtEl>
+                                    <p:spTgt spid="6"/>
+                                  </p:tgtEl>
+                                  <p:attrNameLst>
+                                    <p:attrName>style.visibility</p:attrName>
+                                  </p:attrNameLst>
+                                </p:cBhvr>
+                                <p:to>
+                                  <p:strVal val="visible"/>
+                                </p:to>
+                              </p:set>
+                              <p:animEffect transition="in" filter="fade">
+                                <p:cBhvr>
+                                  <p:cTn id="6" dur="450"/>
+                                  <p:tgtEl>
+                                    <p:spTgt spid="6"/>
+                                  </p:tgtEl>
+                                </p:cBhvr>
+                              </p:animEffect>
+                            </p:childTnLst>
+                          </p:cTn>
+                        </p:par>
+                      </p:childTnLst>
+                    </p:cTn>
+                  </p:par>
+                  <p:par>
+                    <p:cTn id="7" fill="hold">
+                      <p:stCondLst>
+                        <p:cond delay="180"/>
+                      </p:stCondLst>
+                      <p:childTnLst>
+                        <p:par>
+                          <p:cTn id="8" presetID="10" presetClass="entr" presetSubtype="0" fill="hold" nodeType="withEffect">
+                            <p:stCondLst>
+                              <p:cond delay="0"/>
+                            </p:stCondLst>
+                            <p:childTnLst>
+                              <p:set>
+                                <p:cBhvr>
+                                  <p:cTn id="9" dur="1" fill="hold">
+                                    <p:stCondLst>
+                                      <p:cond delay="0"/>
+                                    </p:stCondLst>
+                                  </p:cTn>
+                                  <p:tgtEl>
+                                    <p:spTgt spid="7"/>
+                                  </p:tgtEl>
+                                  <p:attrNameLst>
+                                    <p:attrName>style.visibility</p:attrName>
+                                  </p:attrNameLst>
+                                </p:cBhvr>
+                                <p:to>
+                                  <p:strVal val="visible"/>
+                                </p:to>
+                              </p:set>
+                              <p:animEffect transition="in" filter="fade">
+                                <p:cBhvr>
+                                  <p:cTn id="10" dur="450"/>
+                                  <p:tgtEl>
+                                    <p:spTgt spid="7"/>
+                                  </p:tgtEl>
+                                </p:cBhvr>
+                              </p:animEffect>
+                            </p:childTnLst>
+                          </p:cTn>
+                        </p:par>
+                      </p:childTnLst>
+                    </p:cTn>
+                  </p:par>
+                  <p:par>
+                    <p:cTn id="11" fill="hold">
+                      <p:stCondLst>
+                        <p:cond delay="360"/>
+                      </p:stCondLst>
+                      <p:childTnLst>
+                        <p:par>
+                          <p:cTn id="12" presetID="10" presetClass="entr" presetSubtype="0" fill="hold" nodeType="withEffect">
+                            <p:stCondLst>
+                              <p:cond delay="0"/>
+                            </p:stCondLst>
+                            <p:childTnLst>
+                              <p:set>
+                                <p:cBhvr>
+                                  <p:cTn id="13" dur="1" fill="hold">
+                                    <p:stCondLst>
+                                      <p:cond delay="0"/>
+                                    </p:stCondLst>
+                                  </p:cTn>
+                                  <p:tgtEl>
+                                    <p:spTgt spid="8"/>
+                                  </p:tgtEl>
+                                  <p:attrNameLst>
+                                    <p:attrName>style.visibility</p:attrName>
+                                  </p:attrNameLst>
+                                </p:cBhvr>
+                                <p:to>
+                                  <p:strVal val="visible"/>
+                                </p:to>
+                              </p:set>
+                              <p:animEffect transition="in" filter="fade">
+                                <p:cBhvr>
+                                  <p:cTn id="14" dur="450"/>
+                                  <p:tgtEl>
+                                    <p:spTgt spid="8"/>
+                                  </p:tgtEl>
+                                </p:cBhvr>
+                              </p:animEffect>
+                            </p:childTnLst>
+                          </p:cTn>
+                        </p:par>
+                      </p:childTnLst>
+                    </p:cTn>
+                  </p:par>
+                  <p:par>
+                    <p:cTn id="15" fill="hold">
+                      <p:stCondLst>
+                        <p:cond delay="540"/>
+                      </p:stCondLst>
+                      <p:childTnLst>
+                        <p:par>
+                          <p:cTn id="16" presetID="10" presetClass="entr" presetSubtype="0" fill="hold" nodeType="withEffect">
+                            <p:stCondLst>
+                              <p:cond delay="0"/>
+                            </p:stCondLst>
+                            <p:childTnLst>
+                              <p:set>
+                                <p:cBhvr>
+                                  <p:cTn id="17" dur="1" fill="hold">
+                                    <p:stCondLst>
+                                      <p:cond delay="0"/>
+                                    </p:stCondLst>
+                                  </p:cTn>
+                                  <p:tgtEl>
+                                    <p:spTgt spid="9"/>
+                                  </p:tgtEl>
+                                  <p:attrNameLst>
+                                    <p:attrName>style.visibility</p:attrName>
+                                  </p:attrNameLst>
+                                </p:cBhvr>
+                                <p:to>
+                                  <p:strVal val="visible"/>
+                                </p:to>
+                              </p:set>
+                              <p:animEffect transition="in" filter="fade">
+                                <p:cBhvr>
+                                  <p:cTn id="18" dur="450"/>
+                                  <p:tgtEl>
+                                    <p:spTgt spid="9"/>
+                                  </p:tgtEl>
+                                </p:cBhvr>
+                              </p:animEffect>
+                            </p:childTnLst>
+                          </p:cTn>
+                        </p:par>
+                      </p:childTnLst>
+                    </p:cTn>
+                  </p:par>
+                  <p:par>
+                    <p:cTn id="19" fill="hold">
+                      <p:stCondLst>
+                        <p:cond delay="720"/>
+                      </p:stCondLst>
+                      <p:childTnLst>
+                        <p:par>
+                          <p:cTn id="20" presetID="10" presetClass="entr" presetSubtype="0" fill="hold" nodeType="withEffect">
+                            <p:stCondLst>
+                              <p:cond delay="0"/>
+                            </p:stCondLst>
+                            <p:childTnLst>
+                              <p:set>
+                                <p:cBhvr>
+                                  <p:cTn id="21" dur="1" fill="hold">
+                                    <p:stCondLst>
+                                      <p:cond delay="0"/>
+                                    </p:stCondLst>
+                                  </p:cTn>
+                                  <p:tgtEl>
+                                    <p:spTgt spid="10"/>
+                                  </p:tgtEl>
+                                  <p:attrNameLst>
+                                    <p:attrName>style.visibility</p:attrName>
+                                  </p:attrNameLst>
+                                </p:cBhvr>
+                                <p:to>
+                                  <p:strVal val="visible"/>
+                                </p:to>
+                              </p:set>
+                              <p:animEffect transition="in" filter="fade">
+                                <p:cBhvr>
+                                  <p:cTn id="22" dur="450"/>
+                                  <p:tgtEl>
+                                    <p:spTgt spid="10"/>
+                                  </p:tgtEl>
+                                </p:cBhvr>
+                              </p:animEffect>
+                            </p:childTnLst>
+                          </p:cTn>
+                        </p:par>
+                      </p:childTnLst>
+                    </p:cTn>
+                  </p:par>
+                  <p:par>
+                    <p:cTn id="23" fill="hold">
+                      <p:stCondLst>
+                        <p:cond delay="900"/>
+                      </p:stCondLst>
+                      <p:childTnLst>
+                        <p:par>
+                          <p:cTn id="24" presetID="10" presetClass="entr" presetSubtype="0" fill="hold" nodeType="withEffect">
+                            <p:stCondLst>
+                              <p:cond delay="0"/>
+                            </p:stCondLst>
+                            <p:childTnLst>
+                              <p:set>
+                                <p:cBhvr>
+                                  <p:cTn id="25" dur="1" fill="hold">
+                                    <p:stCondLst>
+                                      <p:cond delay="0"/>
+                                    </p:stCondLst>
+                                  </p:cTn>
+                                  <p:tgtEl>
+                                    <p:spTgt spid="11"/>
+                                  </p:tgtEl>
+                                  <p:attrNameLst>
+                                    <p:attrName>style.visibility</p:attrName>
+                                  </p:attrNameLst>
+                                </p:cBhvr>
+                                <p:to>
+                                  <p:strVal val="visible"/>
+                                </p:to>
+                              </p:set>
+                              <p:animEffect transition="in" filter="fade">
+                                <p:cBhvr>
+                                  <p:cTn id="26" dur="450"/>
+                                  <p:tgtEl>
+                                    <p:spTgt spid="11"/>
+                                  </p:tgtEl>
+                                </p:cBhvr>
+                              </p:animEffect>
+                            </p:childTnLst>
+                          </p:cTn>
+                        </p:par>
+                      </p:childTnLst>
+                    </p:cTn>
+                  </p:par>
+                  <p:par>
+                    <p:cTn id="27" fill="hold">
+                      <p:stCondLst>
+                        <p:cond delay="1080"/>
+                      </p:stCondLst>
+                      <p:childTnLst>
+                        <p:par>
+                          <p:cTn id="28" presetID="10" presetClass="entr" presetSubtype="0" fill="hold" nodeType="withEffect">
+                            <p:stCondLst>
+                              <p:cond delay="0"/>
+                            </p:stCondLst>
+                            <p:childTnLst>
+                              <p:set>
+                                <p:cBhvr>
+                                  <p:cTn id="29" dur="1" fill="hold">
+                                    <p:stCondLst>
+                                      <p:cond delay="0"/>
+                                    </p:stCondLst>
+                                  </p:cTn>
+                                  <p:tgtEl>
+                                    <p:spTgt spid="12"/>
+                                  </p:tgtEl>
+                                  <p:attrNameLst>
+                                    <p:attrName>style.visibility</p:attrName>
+                                  </p:attrNameLst>
+                                </p:cBhvr>
+                                <p:to>
+                                  <p:strVal val="visible"/>
+                                </p:to>
+                              </p:set>
+                              <p:animEffect transition="in" filter="fade">
+                                <p:cBhvr>
+                                  <p:cTn id="30" dur="450"/>
+                                  <p:tgtEl>
+                                    <p:spTgt spid="12"/>
+                                  </p:tgtEl>
+                                </p:cBhvr>
+                              </p:animEffect>
+                            </p:childTnLst>
+                          </p:cTn>
+                        </p:par>
+                      </p:childTnLst>
+                    </p:cTn>
+                  </p:par>
+                </p:childTnLst>
+              </p:cTn>
+              <p:prevCondLst>
+                <p:cond evt="onPrev" delay="0">
+                  <p:tgtEl>
+                    <p:sldTgt/>
+                  </p:tgtEl>
+                </p:cond>
+              </p:prevCondLst>
+              <p:nextCondLst>
+                <p:cond evt="onNext" delay="0">
+                  <p:tgtEl>
+                    <p:sldTgt/>
+                  </p:tgtEl>
+                </p:cond>
+              </p:nextCondLst>
+            </p:seq>
+          </p:childTnLst>
+        </p:cTn>
+      </p:par>
+    </p:tnLst>
+  </p:timing>
 </p:sld>
 </file>
 
@@ -3164,6 +4516,300 @@
   <p:transition spd="med">
     <p:fade/>
   </p:transition>
+  <p:timing>
+    <p:tnLst>
+      <p:par>
+        <p:cTn id="1" dur="indefinite" restart="never" nodeType="tmRoot">
+          <p:childTnLst>
+            <p:seq concurrent="1" nextAc="seek">
+              <p:cTn id="2" dur="indefinite" nodeType="mainSeq">
+                <p:childTnLst>
+                  <p:par>
+                    <p:cTn id="3" fill="hold">
+                      <p:stCondLst>
+                        <p:cond delay="0"/>
+                      </p:stCondLst>
+                      <p:childTnLst>
+                        <p:par>
+                          <p:cTn id="4" presetID="10" presetClass="entr" presetSubtype="0" fill="hold" nodeType="withEffect">
+                            <p:stCondLst>
+                              <p:cond delay="0"/>
+                            </p:stCondLst>
+                            <p:childTnLst>
+                              <p:set>
+                                <p:cBhvr>
+                                  <p:cTn id="5" dur="1" fill="hold">
+                                    <p:stCondLst>
+                                      <p:cond delay="0"/>
+                                    </p:stCondLst>
+                                  </p:cTn>
+                                  <p:tgtEl>
+                                    <p:spTgt spid="6"/>
+                                  </p:tgtEl>
+                                  <p:attrNameLst>
+                                    <p:attrName>style.visibility</p:attrName>
+                                  </p:attrNameLst>
+                                </p:cBhvr>
+                                <p:to>
+                                  <p:strVal val="visible"/>
+                                </p:to>
+                              </p:set>
+                              <p:animEffect transition="in" filter="fade">
+                                <p:cBhvr>
+                                  <p:cTn id="6" dur="450"/>
+                                  <p:tgtEl>
+                                    <p:spTgt spid="6"/>
+                                  </p:tgtEl>
+                                </p:cBhvr>
+                              </p:animEffect>
+                            </p:childTnLst>
+                          </p:cTn>
+                        </p:par>
+                      </p:childTnLst>
+                    </p:cTn>
+                  </p:par>
+                  <p:par>
+                    <p:cTn id="7" fill="hold">
+                      <p:stCondLst>
+                        <p:cond delay="180"/>
+                      </p:stCondLst>
+                      <p:childTnLst>
+                        <p:par>
+                          <p:cTn id="8" presetID="10" presetClass="entr" presetSubtype="0" fill="hold" nodeType="withEffect">
+                            <p:stCondLst>
+                              <p:cond delay="0"/>
+                            </p:stCondLst>
+                            <p:childTnLst>
+                              <p:set>
+                                <p:cBhvr>
+                                  <p:cTn id="9" dur="1" fill="hold">
+                                    <p:stCondLst>
+                                      <p:cond delay="0"/>
+                                    </p:stCondLst>
+                                  </p:cTn>
+                                  <p:tgtEl>
+                                    <p:spTgt spid="7"/>
+                                  </p:tgtEl>
+                                  <p:attrNameLst>
+                                    <p:attrName>style.visibility</p:attrName>
+                                  </p:attrNameLst>
+                                </p:cBhvr>
+                                <p:to>
+                                  <p:strVal val="visible"/>
+                                </p:to>
+                              </p:set>
+                              <p:animEffect transition="in" filter="fade">
+                                <p:cBhvr>
+                                  <p:cTn id="10" dur="450"/>
+                                  <p:tgtEl>
+                                    <p:spTgt spid="7"/>
+                                  </p:tgtEl>
+                                </p:cBhvr>
+                              </p:animEffect>
+                            </p:childTnLst>
+                          </p:cTn>
+                        </p:par>
+                      </p:childTnLst>
+                    </p:cTn>
+                  </p:par>
+                  <p:par>
+                    <p:cTn id="11" fill="hold">
+                      <p:stCondLst>
+                        <p:cond delay="360"/>
+                      </p:stCondLst>
+                      <p:childTnLst>
+                        <p:par>
+                          <p:cTn id="12" presetID="10" presetClass="entr" presetSubtype="0" fill="hold" nodeType="withEffect">
+                            <p:stCondLst>
+                              <p:cond delay="0"/>
+                            </p:stCondLst>
+                            <p:childTnLst>
+                              <p:set>
+                                <p:cBhvr>
+                                  <p:cTn id="13" dur="1" fill="hold">
+                                    <p:stCondLst>
+                                      <p:cond delay="0"/>
+                                    </p:stCondLst>
+                                  </p:cTn>
+                                  <p:tgtEl>
+                                    <p:spTgt spid="8"/>
+                                  </p:tgtEl>
+                                  <p:attrNameLst>
+                                    <p:attrName>style.visibility</p:attrName>
+                                  </p:attrNameLst>
+                                </p:cBhvr>
+                                <p:to>
+                                  <p:strVal val="visible"/>
+                                </p:to>
+                              </p:set>
+                              <p:animEffect transition="in" filter="fade">
+                                <p:cBhvr>
+                                  <p:cTn id="14" dur="450"/>
+                                  <p:tgtEl>
+                                    <p:spTgt spid="8"/>
+                                  </p:tgtEl>
+                                </p:cBhvr>
+                              </p:animEffect>
+                            </p:childTnLst>
+                          </p:cTn>
+                        </p:par>
+                      </p:childTnLst>
+                    </p:cTn>
+                  </p:par>
+                  <p:par>
+                    <p:cTn id="15" fill="hold">
+                      <p:stCondLst>
+                        <p:cond delay="540"/>
+                      </p:stCondLst>
+                      <p:childTnLst>
+                        <p:par>
+                          <p:cTn id="16" presetID="10" presetClass="entr" presetSubtype="0" fill="hold" nodeType="withEffect">
+                            <p:stCondLst>
+                              <p:cond delay="0"/>
+                            </p:stCondLst>
+                            <p:childTnLst>
+                              <p:set>
+                                <p:cBhvr>
+                                  <p:cTn id="17" dur="1" fill="hold">
+                                    <p:stCondLst>
+                                      <p:cond delay="0"/>
+                                    </p:stCondLst>
+                                  </p:cTn>
+                                  <p:tgtEl>
+                                    <p:spTgt spid="9"/>
+                                  </p:tgtEl>
+                                  <p:attrNameLst>
+                                    <p:attrName>style.visibility</p:attrName>
+                                  </p:attrNameLst>
+                                </p:cBhvr>
+                                <p:to>
+                                  <p:strVal val="visible"/>
+                                </p:to>
+                              </p:set>
+                              <p:animEffect transition="in" filter="fade">
+                                <p:cBhvr>
+                                  <p:cTn id="18" dur="450"/>
+                                  <p:tgtEl>
+                                    <p:spTgt spid="9"/>
+                                  </p:tgtEl>
+                                </p:cBhvr>
+                              </p:animEffect>
+                            </p:childTnLst>
+                          </p:cTn>
+                        </p:par>
+                      </p:childTnLst>
+                    </p:cTn>
+                  </p:par>
+                  <p:par>
+                    <p:cTn id="19" fill="hold">
+                      <p:stCondLst>
+                        <p:cond delay="720"/>
+                      </p:stCondLst>
+                      <p:childTnLst>
+                        <p:par>
+                          <p:cTn id="20" presetID="10" presetClass="entr" presetSubtype="0" fill="hold" nodeType="withEffect">
+                            <p:stCondLst>
+                              <p:cond delay="0"/>
+                            </p:stCondLst>
+                            <p:childTnLst>
+                              <p:set>
+                                <p:cBhvr>
+                                  <p:cTn id="21" dur="1" fill="hold">
+                                    <p:stCondLst>
+                                      <p:cond delay="0"/>
+                                    </p:stCondLst>
+                                  </p:cTn>
+                                  <p:tgtEl>
+                                    <p:spTgt spid="10"/>
+                                  </p:tgtEl>
+                                  <p:attrNameLst>
+                                    <p:attrName>style.visibility</p:attrName>
+                                  </p:attrNameLst>
+                                </p:cBhvr>
+                                <p:to>
+                                  <p:strVal val="visible"/>
+                                </p:to>
+                              </p:set>
+                              <p:animEffect transition="in" filter="fade">
+                                <p:cBhvr>
+                                  <p:cTn id="22" dur="450"/>
+                                  <p:tgtEl>
+                                    <p:spTgt spid="10"/>
+                                  </p:tgtEl>
+                                </p:cBhvr>
+                              </p:animEffect>
+                            </p:childTnLst>
+                          </p:cTn>
+                        </p:par>
+                      </p:childTnLst>
+                    </p:cTn>
+                  </p:par>
+                  <p:par>
+                    <p:cTn id="23" fill="hold">
+                      <p:stCondLst>
+                        <p:cond delay="900"/>
+                      </p:stCondLst>
+                      <p:childTnLst>
+                        <p:par>
+                          <p:cTn id="24" presetID="10" presetClass="entr" presetSubtype="0" fill="hold" nodeType="withEffect">
+                            <p:stCondLst>
+                              <p:cond delay="0"/>
+                            </p:stCondLst>
+                            <p:childTnLst>
+                              <p:set>
+                                <p:cBhvr>
+                                  <p:cTn id="25" dur="1" fill="hold">
+                                    <p:stCondLst>
+                                      <p:cond delay="0"/>
+                                    </p:stCondLst>
+                                  </p:cTn>
+                                  <p:tgtEl>
+                                    <p:spTgt spid="11"/>
+                                  </p:tgtEl>
+                                  <p:attrNameLst>
+                                    <p:attrName>style.visibility</p:attrName>
+                                  </p:attrNameLst>
+                                </p:cBhvr>
+                                <p:to>
+                                  <p:strVal val="visible"/>
+                                </p:to>
+                              </p:set>
+                              <p:animEffect transition="in" filter="fade">
+                                <p:cBhvr>
+                                  <p:cTn id="26" dur="450"/>
+                                  <p:tgtEl>
+                                    <p:spTgt spid="11"/>
+                                  </p:tgtEl>
+                                </p:cBhvr>
+                              </p:animEffect>
+                            </p:childTnLst>
+                          </p:cTn>
+                        </p:par>
+                      </p:childTnLst>
+                    </p:cTn>
+                  </p:par>
+                </p:childTnLst>
+              </p:cTn>
+              <p:prevCondLst>
+                <p:cond evt="onPrev" delay="0">
+                  <p:tgtEl>
+                    <p:sldTgt/>
+                  </p:tgtEl>
+                </p:cond>
+              </p:prevCondLst>
+              <p:nextCondLst>
+                <p:cond evt="onNext" delay="0">
+                  <p:tgtEl>
+                    <p:sldTgt/>
+                  </p:tgtEl>
+                </p:cond>
+              </p:nextCondLst>
+            </p:seq>
+          </p:childTnLst>
+        </p:cTn>
+      </p:par>
+    </p:tnLst>
+  </p:timing>
 </p:sld>
 </file>
 
@@ -3720,6 +5366,256 @@
   <p:transition spd="med">
     <p:fade/>
   </p:transition>
+  <p:timing>
+    <p:tnLst>
+      <p:par>
+        <p:cTn id="1" dur="indefinite" restart="never" nodeType="tmRoot">
+          <p:childTnLst>
+            <p:seq concurrent="1" nextAc="seek">
+              <p:cTn id="2" dur="indefinite" nodeType="mainSeq">
+                <p:childTnLst>
+                  <p:par>
+                    <p:cTn id="3" fill="hold">
+                      <p:stCondLst>
+                        <p:cond delay="0"/>
+                      </p:stCondLst>
+                      <p:childTnLst>
+                        <p:par>
+                          <p:cTn id="4" presetID="10" presetClass="entr" presetSubtype="0" fill="hold" nodeType="withEffect">
+                            <p:stCondLst>
+                              <p:cond delay="0"/>
+                            </p:stCondLst>
+                            <p:childTnLst>
+                              <p:set>
+                                <p:cBhvr>
+                                  <p:cTn id="5" dur="1" fill="hold">
+                                    <p:stCondLst>
+                                      <p:cond delay="0"/>
+                                    </p:stCondLst>
+                                  </p:cTn>
+                                  <p:tgtEl>
+                                    <p:spTgt spid="6"/>
+                                  </p:tgtEl>
+                                  <p:attrNameLst>
+                                    <p:attrName>style.visibility</p:attrName>
+                                  </p:attrNameLst>
+                                </p:cBhvr>
+                                <p:to>
+                                  <p:strVal val="visible"/>
+                                </p:to>
+                              </p:set>
+                              <p:animEffect transition="in" filter="fade">
+                                <p:cBhvr>
+                                  <p:cTn id="6" dur="450"/>
+                                  <p:tgtEl>
+                                    <p:spTgt spid="6"/>
+                                  </p:tgtEl>
+                                </p:cBhvr>
+                              </p:animEffect>
+                            </p:childTnLst>
+                          </p:cTn>
+                        </p:par>
+                      </p:childTnLst>
+                    </p:cTn>
+                  </p:par>
+                  <p:par>
+                    <p:cTn id="7" fill="hold">
+                      <p:stCondLst>
+                        <p:cond delay="180"/>
+                      </p:stCondLst>
+                      <p:childTnLst>
+                        <p:par>
+                          <p:cTn id="8" presetID="10" presetClass="entr" presetSubtype="0" fill="hold" nodeType="withEffect">
+                            <p:stCondLst>
+                              <p:cond delay="0"/>
+                            </p:stCondLst>
+                            <p:childTnLst>
+                              <p:set>
+                                <p:cBhvr>
+                                  <p:cTn id="9" dur="1" fill="hold">
+                                    <p:stCondLst>
+                                      <p:cond delay="0"/>
+                                    </p:stCondLst>
+                                  </p:cTn>
+                                  <p:tgtEl>
+                                    <p:spTgt spid="7"/>
+                                  </p:tgtEl>
+                                  <p:attrNameLst>
+                                    <p:attrName>style.visibility</p:attrName>
+                                  </p:attrNameLst>
+                                </p:cBhvr>
+                                <p:to>
+                                  <p:strVal val="visible"/>
+                                </p:to>
+                              </p:set>
+                              <p:animEffect transition="in" filter="fade">
+                                <p:cBhvr>
+                                  <p:cTn id="10" dur="450"/>
+                                  <p:tgtEl>
+                                    <p:spTgt spid="7"/>
+                                  </p:tgtEl>
+                                </p:cBhvr>
+                              </p:animEffect>
+                            </p:childTnLst>
+                          </p:cTn>
+                        </p:par>
+                      </p:childTnLst>
+                    </p:cTn>
+                  </p:par>
+                  <p:par>
+                    <p:cTn id="11" fill="hold">
+                      <p:stCondLst>
+                        <p:cond delay="360"/>
+                      </p:stCondLst>
+                      <p:childTnLst>
+                        <p:par>
+                          <p:cTn id="12" presetID="10" presetClass="entr" presetSubtype="0" fill="hold" nodeType="withEffect">
+                            <p:stCondLst>
+                              <p:cond delay="0"/>
+                            </p:stCondLst>
+                            <p:childTnLst>
+                              <p:set>
+                                <p:cBhvr>
+                                  <p:cTn id="13" dur="1" fill="hold">
+                                    <p:stCondLst>
+                                      <p:cond delay="0"/>
+                                    </p:stCondLst>
+                                  </p:cTn>
+                                  <p:tgtEl>
+                                    <p:spTgt spid="8"/>
+                                  </p:tgtEl>
+                                  <p:attrNameLst>
+                                    <p:attrName>style.visibility</p:attrName>
+                                  </p:attrNameLst>
+                                </p:cBhvr>
+                                <p:to>
+                                  <p:strVal val="visible"/>
+                                </p:to>
+                              </p:set>
+                              <p:animEffect transition="in" filter="fade">
+                                <p:cBhvr>
+                                  <p:cTn id="14" dur="450"/>
+                                  <p:tgtEl>
+                                    <p:spTgt spid="8"/>
+                                  </p:tgtEl>
+                                </p:cBhvr>
+                              </p:animEffect>
+                            </p:childTnLst>
+                          </p:cTn>
+                        </p:par>
+                      </p:childTnLst>
+                    </p:cTn>
+                  </p:par>
+                  <p:par>
+                    <p:cTn id="15" fill="hold">
+                      <p:stCondLst>
+                        <p:cond delay="540"/>
+                      </p:stCondLst>
+                      <p:childTnLst>
+                        <p:par>
+                          <p:cTn id="16" presetID="10" presetClass="entr" presetSubtype="0" fill="hold" nodeType="withEffect">
+                            <p:stCondLst>
+                              <p:cond delay="0"/>
+                            </p:stCondLst>
+                            <p:childTnLst>
+                              <p:set>
+                                <p:cBhvr>
+                                  <p:cTn id="17" dur="1" fill="hold">
+                                    <p:stCondLst>
+                                      <p:cond delay="0"/>
+                                    </p:stCondLst>
+                                  </p:cTn>
+                                  <p:tgtEl>
+                                    <p:spTgt spid="9"/>
+                                  </p:tgtEl>
+                                  <p:attrNameLst>
+                                    <p:attrName>style.visibility</p:attrName>
+                                  </p:attrNameLst>
+                                </p:cBhvr>
+                                <p:to>
+                                  <p:strVal val="visible"/>
+                                </p:to>
+                              </p:set>
+                              <p:animEffect transition="in" filter="fade">
+                                <p:cBhvr>
+                                  <p:cTn id="18" dur="450"/>
+                                  <p:tgtEl>
+                                    <p:spTgt spid="9"/>
+                                  </p:tgtEl>
+                                </p:cBhvr>
+                              </p:animEffect>
+                            </p:childTnLst>
+                          </p:cTn>
+                        </p:par>
+                      </p:childTnLst>
+                    </p:cTn>
+                  </p:par>
+                  <p:par>
+                    <p:cTn id="19" fill="hold">
+                      <p:stCondLst>
+                        <p:cond delay="720"/>
+                      </p:stCondLst>
+                      <p:childTnLst>
+                        <p:par>
+                          <p:cTn id="20" presetID="10" presetClass="entr" presetSubtype="0" fill="hold" nodeType="withEffect">
+                            <p:stCondLst>
+                              <p:cond delay="0"/>
+                            </p:stCondLst>
+                            <p:childTnLst>
+                              <p:set>
+                                <p:cBhvr>
+                                  <p:cTn id="21" dur="1" fill="hold">
+                                    <p:stCondLst>
+                                      <p:cond delay="0"/>
+                                    </p:stCondLst>
+                                  </p:cTn>
+                                  <p:tgtEl>
+                                    <p:spTgt spid="10"/>
+                                  </p:tgtEl>
+                                  <p:attrNameLst>
+                                    <p:attrName>style.visibility</p:attrName>
+                                  </p:attrNameLst>
+                                </p:cBhvr>
+                                <p:to>
+                                  <p:strVal val="visible"/>
+                                </p:to>
+                              </p:set>
+                              <p:animEffect transition="in" filter="fade">
+                                <p:cBhvr>
+                                  <p:cTn id="22" dur="450"/>
+                                  <p:tgtEl>
+                                    <p:spTgt spid="10"/>
+                                  </p:tgtEl>
+                                </p:cBhvr>
+                              </p:animEffect>
+                            </p:childTnLst>
+                          </p:cTn>
+                        </p:par>
+                      </p:childTnLst>
+                    </p:cTn>
+                  </p:par>
+                </p:childTnLst>
+              </p:cTn>
+              <p:prevCondLst>
+                <p:cond evt="onPrev" delay="0">
+                  <p:tgtEl>
+                    <p:sldTgt/>
+                  </p:tgtEl>
+                </p:cond>
+              </p:prevCondLst>
+              <p:nextCondLst>
+                <p:cond evt="onNext" delay="0">
+                  <p:tgtEl>
+                    <p:sldTgt/>
+                  </p:tgtEl>
+                </p:cond>
+              </p:nextCondLst>
+            </p:seq>
+          </p:childTnLst>
+        </p:cTn>
+      </p:par>
+    </p:tnLst>
+  </p:timing>
 </p:sld>
 </file>
 
@@ -4646,6 +6542,300 @@
   <p:transition spd="med">
     <p:fade/>
   </p:transition>
+  <p:timing>
+    <p:tnLst>
+      <p:par>
+        <p:cTn id="1" dur="indefinite" restart="never" nodeType="tmRoot">
+          <p:childTnLst>
+            <p:seq concurrent="1" nextAc="seek">
+              <p:cTn id="2" dur="indefinite" nodeType="mainSeq">
+                <p:childTnLst>
+                  <p:par>
+                    <p:cTn id="3" fill="hold">
+                      <p:stCondLst>
+                        <p:cond delay="0"/>
+                      </p:stCondLst>
+                      <p:childTnLst>
+                        <p:par>
+                          <p:cTn id="4" presetID="10" presetClass="entr" presetSubtype="0" fill="hold" nodeType="withEffect">
+                            <p:stCondLst>
+                              <p:cond delay="0"/>
+                            </p:stCondLst>
+                            <p:childTnLst>
+                              <p:set>
+                                <p:cBhvr>
+                                  <p:cTn id="5" dur="1" fill="hold">
+                                    <p:stCondLst>
+                                      <p:cond delay="0"/>
+                                    </p:stCondLst>
+                                  </p:cTn>
+                                  <p:tgtEl>
+                                    <p:spTgt spid="6"/>
+                                  </p:tgtEl>
+                                  <p:attrNameLst>
+                                    <p:attrName>style.visibility</p:attrName>
+                                  </p:attrNameLst>
+                                </p:cBhvr>
+                                <p:to>
+                                  <p:strVal val="visible"/>
+                                </p:to>
+                              </p:set>
+                              <p:animEffect transition="in" filter="fade">
+                                <p:cBhvr>
+                                  <p:cTn id="6" dur="450"/>
+                                  <p:tgtEl>
+                                    <p:spTgt spid="6"/>
+                                  </p:tgtEl>
+                                </p:cBhvr>
+                              </p:animEffect>
+                            </p:childTnLst>
+                          </p:cTn>
+                        </p:par>
+                      </p:childTnLst>
+                    </p:cTn>
+                  </p:par>
+                  <p:par>
+                    <p:cTn id="7" fill="hold">
+                      <p:stCondLst>
+                        <p:cond delay="180"/>
+                      </p:stCondLst>
+                      <p:childTnLst>
+                        <p:par>
+                          <p:cTn id="8" presetID="10" presetClass="entr" presetSubtype="0" fill="hold" nodeType="withEffect">
+                            <p:stCondLst>
+                              <p:cond delay="0"/>
+                            </p:stCondLst>
+                            <p:childTnLst>
+                              <p:set>
+                                <p:cBhvr>
+                                  <p:cTn id="9" dur="1" fill="hold">
+                                    <p:stCondLst>
+                                      <p:cond delay="0"/>
+                                    </p:stCondLst>
+                                  </p:cTn>
+                                  <p:tgtEl>
+                                    <p:spTgt spid="7"/>
+                                  </p:tgtEl>
+                                  <p:attrNameLst>
+                                    <p:attrName>style.visibility</p:attrName>
+                                  </p:attrNameLst>
+                                </p:cBhvr>
+                                <p:to>
+                                  <p:strVal val="visible"/>
+                                </p:to>
+                              </p:set>
+                              <p:animEffect transition="in" filter="fade">
+                                <p:cBhvr>
+                                  <p:cTn id="10" dur="450"/>
+                                  <p:tgtEl>
+                                    <p:spTgt spid="7"/>
+                                  </p:tgtEl>
+                                </p:cBhvr>
+                              </p:animEffect>
+                            </p:childTnLst>
+                          </p:cTn>
+                        </p:par>
+                      </p:childTnLst>
+                    </p:cTn>
+                  </p:par>
+                  <p:par>
+                    <p:cTn id="11" fill="hold">
+                      <p:stCondLst>
+                        <p:cond delay="360"/>
+                      </p:stCondLst>
+                      <p:childTnLst>
+                        <p:par>
+                          <p:cTn id="12" presetID="10" presetClass="entr" presetSubtype="0" fill="hold" nodeType="withEffect">
+                            <p:stCondLst>
+                              <p:cond delay="0"/>
+                            </p:stCondLst>
+                            <p:childTnLst>
+                              <p:set>
+                                <p:cBhvr>
+                                  <p:cTn id="13" dur="1" fill="hold">
+                                    <p:stCondLst>
+                                      <p:cond delay="0"/>
+                                    </p:stCondLst>
+                                  </p:cTn>
+                                  <p:tgtEl>
+                                    <p:spTgt spid="8"/>
+                                  </p:tgtEl>
+                                  <p:attrNameLst>
+                                    <p:attrName>style.visibility</p:attrName>
+                                  </p:attrNameLst>
+                                </p:cBhvr>
+                                <p:to>
+                                  <p:strVal val="visible"/>
+                                </p:to>
+                              </p:set>
+                              <p:animEffect transition="in" filter="fade">
+                                <p:cBhvr>
+                                  <p:cTn id="14" dur="450"/>
+                                  <p:tgtEl>
+                                    <p:spTgt spid="8"/>
+                                  </p:tgtEl>
+                                </p:cBhvr>
+                              </p:animEffect>
+                            </p:childTnLst>
+                          </p:cTn>
+                        </p:par>
+                      </p:childTnLst>
+                    </p:cTn>
+                  </p:par>
+                  <p:par>
+                    <p:cTn id="15" fill="hold">
+                      <p:stCondLst>
+                        <p:cond delay="540"/>
+                      </p:stCondLst>
+                      <p:childTnLst>
+                        <p:par>
+                          <p:cTn id="16" presetID="10" presetClass="entr" presetSubtype="0" fill="hold" nodeType="withEffect">
+                            <p:stCondLst>
+                              <p:cond delay="0"/>
+                            </p:stCondLst>
+                            <p:childTnLst>
+                              <p:set>
+                                <p:cBhvr>
+                                  <p:cTn id="17" dur="1" fill="hold">
+                                    <p:stCondLst>
+                                      <p:cond delay="0"/>
+                                    </p:stCondLst>
+                                  </p:cTn>
+                                  <p:tgtEl>
+                                    <p:spTgt spid="9"/>
+                                  </p:tgtEl>
+                                  <p:attrNameLst>
+                                    <p:attrName>style.visibility</p:attrName>
+                                  </p:attrNameLst>
+                                </p:cBhvr>
+                                <p:to>
+                                  <p:strVal val="visible"/>
+                                </p:to>
+                              </p:set>
+                              <p:animEffect transition="in" filter="fade">
+                                <p:cBhvr>
+                                  <p:cTn id="18" dur="450"/>
+                                  <p:tgtEl>
+                                    <p:spTgt spid="9"/>
+                                  </p:tgtEl>
+                                </p:cBhvr>
+                              </p:animEffect>
+                            </p:childTnLst>
+                          </p:cTn>
+                        </p:par>
+                      </p:childTnLst>
+                    </p:cTn>
+                  </p:par>
+                  <p:par>
+                    <p:cTn id="19" fill="hold">
+                      <p:stCondLst>
+                        <p:cond delay="720"/>
+                      </p:stCondLst>
+                      <p:childTnLst>
+                        <p:par>
+                          <p:cTn id="20" presetID="10" presetClass="entr" presetSubtype="0" fill="hold" nodeType="withEffect">
+                            <p:stCondLst>
+                              <p:cond delay="0"/>
+                            </p:stCondLst>
+                            <p:childTnLst>
+                              <p:set>
+                                <p:cBhvr>
+                                  <p:cTn id="21" dur="1" fill="hold">
+                                    <p:stCondLst>
+                                      <p:cond delay="0"/>
+                                    </p:stCondLst>
+                                  </p:cTn>
+                                  <p:tgtEl>
+                                    <p:spTgt spid="10"/>
+                                  </p:tgtEl>
+                                  <p:attrNameLst>
+                                    <p:attrName>style.visibility</p:attrName>
+                                  </p:attrNameLst>
+                                </p:cBhvr>
+                                <p:to>
+                                  <p:strVal val="visible"/>
+                                </p:to>
+                              </p:set>
+                              <p:animEffect transition="in" filter="fade">
+                                <p:cBhvr>
+                                  <p:cTn id="22" dur="450"/>
+                                  <p:tgtEl>
+                                    <p:spTgt spid="10"/>
+                                  </p:tgtEl>
+                                </p:cBhvr>
+                              </p:animEffect>
+                            </p:childTnLst>
+                          </p:cTn>
+                        </p:par>
+                      </p:childTnLst>
+                    </p:cTn>
+                  </p:par>
+                  <p:par>
+                    <p:cTn id="23" fill="hold">
+                      <p:stCondLst>
+                        <p:cond delay="900"/>
+                      </p:stCondLst>
+                      <p:childTnLst>
+                        <p:par>
+                          <p:cTn id="24" presetID="10" presetClass="entr" presetSubtype="0" fill="hold" nodeType="withEffect">
+                            <p:stCondLst>
+                              <p:cond delay="0"/>
+                            </p:stCondLst>
+                            <p:childTnLst>
+                              <p:set>
+                                <p:cBhvr>
+                                  <p:cTn id="25" dur="1" fill="hold">
+                                    <p:stCondLst>
+                                      <p:cond delay="0"/>
+                                    </p:stCondLst>
+                                  </p:cTn>
+                                  <p:tgtEl>
+                                    <p:spTgt spid="11"/>
+                                  </p:tgtEl>
+                                  <p:attrNameLst>
+                                    <p:attrName>style.visibility</p:attrName>
+                                  </p:attrNameLst>
+                                </p:cBhvr>
+                                <p:to>
+                                  <p:strVal val="visible"/>
+                                </p:to>
+                              </p:set>
+                              <p:animEffect transition="in" filter="fade">
+                                <p:cBhvr>
+                                  <p:cTn id="26" dur="450"/>
+                                  <p:tgtEl>
+                                    <p:spTgt spid="11"/>
+                                  </p:tgtEl>
+                                </p:cBhvr>
+                              </p:animEffect>
+                            </p:childTnLst>
+                          </p:cTn>
+                        </p:par>
+                      </p:childTnLst>
+                    </p:cTn>
+                  </p:par>
+                </p:childTnLst>
+              </p:cTn>
+              <p:prevCondLst>
+                <p:cond evt="onPrev" delay="0">
+                  <p:tgtEl>
+                    <p:sldTgt/>
+                  </p:tgtEl>
+                </p:cond>
+              </p:prevCondLst>
+              <p:nextCondLst>
+                <p:cond evt="onNext" delay="0">
+                  <p:tgtEl>
+                    <p:sldTgt/>
+                  </p:tgtEl>
+                </p:cond>
+              </p:nextCondLst>
+            </p:seq>
+          </p:childTnLst>
+        </p:cTn>
+      </p:par>
+    </p:tnLst>
+  </p:timing>
 </p:sld>
 </file>
 
@@ -5326,6 +7516,388 @@
   <p:transition spd="med">
     <p:fade/>
   </p:transition>
+  <p:timing>
+    <p:tnLst>
+      <p:par>
+        <p:cTn id="1" dur="indefinite" restart="never" nodeType="tmRoot">
+          <p:childTnLst>
+            <p:seq concurrent="1" nextAc="seek">
+              <p:cTn id="2" dur="indefinite" nodeType="mainSeq">
+                <p:childTnLst>
+                  <p:par>
+                    <p:cTn id="3" fill="hold">
+                      <p:stCondLst>
+                        <p:cond delay="0"/>
+                      </p:stCondLst>
+                      <p:childTnLst>
+                        <p:par>
+                          <p:cTn id="4" presetID="10" presetClass="entr" presetSubtype="0" fill="hold" nodeType="withEffect">
+                            <p:stCondLst>
+                              <p:cond delay="0"/>
+                            </p:stCondLst>
+                            <p:childTnLst>
+                              <p:set>
+                                <p:cBhvr>
+                                  <p:cTn id="5" dur="1" fill="hold">
+                                    <p:stCondLst>
+                                      <p:cond delay="0"/>
+                                    </p:stCondLst>
+                                  </p:cTn>
+                                  <p:tgtEl>
+                                    <p:spTgt spid="6"/>
+                                  </p:tgtEl>
+                                  <p:attrNameLst>
+                                    <p:attrName>style.visibility</p:attrName>
+                                  </p:attrNameLst>
+                                </p:cBhvr>
+                                <p:to>
+                                  <p:strVal val="visible"/>
+                                </p:to>
+                              </p:set>
+                              <p:animEffect transition="in" filter="fade">
+                                <p:cBhvr>
+                                  <p:cTn id="6" dur="450"/>
+                                  <p:tgtEl>
+                                    <p:spTgt spid="6"/>
+                                  </p:tgtEl>
+                                </p:cBhvr>
+                              </p:animEffect>
+                            </p:childTnLst>
+                          </p:cTn>
+                        </p:par>
+                      </p:childTnLst>
+                    </p:cTn>
+                  </p:par>
+                  <p:par>
+                    <p:cTn id="7" fill="hold">
+                      <p:stCondLst>
+                        <p:cond delay="180"/>
+                      </p:stCondLst>
+                      <p:childTnLst>
+                        <p:par>
+                          <p:cTn id="8" presetID="10" presetClass="entr" presetSubtype="0" fill="hold" nodeType="withEffect">
+                            <p:stCondLst>
+                              <p:cond delay="0"/>
+                            </p:stCondLst>
+                            <p:childTnLst>
+                              <p:set>
+                                <p:cBhvr>
+                                  <p:cTn id="9" dur="1" fill="hold">
+                                    <p:stCondLst>
+                                      <p:cond delay="0"/>
+                                    </p:stCondLst>
+                                  </p:cTn>
+                                  <p:tgtEl>
+                                    <p:spTgt spid="7"/>
+                                  </p:tgtEl>
+                                  <p:attrNameLst>
+                                    <p:attrName>style.visibility</p:attrName>
+                                  </p:attrNameLst>
+                                </p:cBhvr>
+                                <p:to>
+                                  <p:strVal val="visible"/>
+                                </p:to>
+                              </p:set>
+                              <p:animEffect transition="in" filter="fade">
+                                <p:cBhvr>
+                                  <p:cTn id="10" dur="450"/>
+                                  <p:tgtEl>
+                                    <p:spTgt spid="7"/>
+                                  </p:tgtEl>
+                                </p:cBhvr>
+                              </p:animEffect>
+                            </p:childTnLst>
+                          </p:cTn>
+                        </p:par>
+                      </p:childTnLst>
+                    </p:cTn>
+                  </p:par>
+                  <p:par>
+                    <p:cTn id="11" fill="hold">
+                      <p:stCondLst>
+                        <p:cond delay="360"/>
+                      </p:stCondLst>
+                      <p:childTnLst>
+                        <p:par>
+                          <p:cTn id="12" presetID="10" presetClass="entr" presetSubtype="0" fill="hold" nodeType="withEffect">
+                            <p:stCondLst>
+                              <p:cond delay="0"/>
+                            </p:stCondLst>
+                            <p:childTnLst>
+                              <p:set>
+                                <p:cBhvr>
+                                  <p:cTn id="13" dur="1" fill="hold">
+                                    <p:stCondLst>
+                                      <p:cond delay="0"/>
+                                    </p:stCondLst>
+                                  </p:cTn>
+                                  <p:tgtEl>
+                                    <p:spTgt spid="8"/>
+                                  </p:tgtEl>
+                                  <p:attrNameLst>
+                                    <p:attrName>style.visibility</p:attrName>
+                                  </p:attrNameLst>
+                                </p:cBhvr>
+                                <p:to>
+                                  <p:strVal val="visible"/>
+                                </p:to>
+                              </p:set>
+                              <p:animEffect transition="in" filter="fade">
+                                <p:cBhvr>
+                                  <p:cTn id="14" dur="450"/>
+                                  <p:tgtEl>
+                                    <p:spTgt spid="8"/>
+                                  </p:tgtEl>
+                                </p:cBhvr>
+                              </p:animEffect>
+                            </p:childTnLst>
+                          </p:cTn>
+                        </p:par>
+                      </p:childTnLst>
+                    </p:cTn>
+                  </p:par>
+                  <p:par>
+                    <p:cTn id="15" fill="hold">
+                      <p:stCondLst>
+                        <p:cond delay="540"/>
+                      </p:stCondLst>
+                      <p:childTnLst>
+                        <p:par>
+                          <p:cTn id="16" presetID="10" presetClass="entr" presetSubtype="0" fill="hold" nodeType="withEffect">
+                            <p:stCondLst>
+                              <p:cond delay="0"/>
+                            </p:stCondLst>
+                            <p:childTnLst>
+                              <p:set>
+                                <p:cBhvr>
+                                  <p:cTn id="17" dur="1" fill="hold">
+                                    <p:stCondLst>
+                                      <p:cond delay="0"/>
+                                    </p:stCondLst>
+                                  </p:cTn>
+                                  <p:tgtEl>
+                                    <p:spTgt spid="9"/>
+                                  </p:tgtEl>
+                                  <p:attrNameLst>
+                                    <p:attrName>style.visibility</p:attrName>
+                                  </p:attrNameLst>
+                                </p:cBhvr>
+                                <p:to>
+                                  <p:strVal val="visible"/>
+                                </p:to>
+                              </p:set>
+                              <p:animEffect transition="in" filter="fade">
+                                <p:cBhvr>
+                                  <p:cTn id="18" dur="450"/>
+                                  <p:tgtEl>
+                                    <p:spTgt spid="9"/>
+                                  </p:tgtEl>
+                                </p:cBhvr>
+                              </p:animEffect>
+                            </p:childTnLst>
+                          </p:cTn>
+                        </p:par>
+                      </p:childTnLst>
+                    </p:cTn>
+                  </p:par>
+                  <p:par>
+                    <p:cTn id="19" fill="hold">
+                      <p:stCondLst>
+                        <p:cond delay="720"/>
+                      </p:stCondLst>
+                      <p:childTnLst>
+                        <p:par>
+                          <p:cTn id="20" presetID="10" presetClass="entr" presetSubtype="0" fill="hold" nodeType="withEffect">
+                            <p:stCondLst>
+                              <p:cond delay="0"/>
+                            </p:stCondLst>
+                            <p:childTnLst>
+                              <p:set>
+                                <p:cBhvr>
+                                  <p:cTn id="21" dur="1" fill="hold">
+                                    <p:stCondLst>
+                                      <p:cond delay="0"/>
+                                    </p:stCondLst>
+                                  </p:cTn>
+                                  <p:tgtEl>
+                                    <p:spTgt spid="10"/>
+                                  </p:tgtEl>
+                                  <p:attrNameLst>
+                                    <p:attrName>style.visibility</p:attrName>
+                                  </p:attrNameLst>
+                                </p:cBhvr>
+                                <p:to>
+                                  <p:strVal val="visible"/>
+                                </p:to>
+                              </p:set>
+                              <p:animEffect transition="in" filter="fade">
+                                <p:cBhvr>
+                                  <p:cTn id="22" dur="450"/>
+                                  <p:tgtEl>
+                                    <p:spTgt spid="10"/>
+                                  </p:tgtEl>
+                                </p:cBhvr>
+                              </p:animEffect>
+                            </p:childTnLst>
+                          </p:cTn>
+                        </p:par>
+                      </p:childTnLst>
+                    </p:cTn>
+                  </p:par>
+                  <p:par>
+                    <p:cTn id="23" fill="hold">
+                      <p:stCondLst>
+                        <p:cond delay="900"/>
+                      </p:stCondLst>
+                      <p:childTnLst>
+                        <p:par>
+                          <p:cTn id="24" presetID="10" presetClass="entr" presetSubtype="0" fill="hold" nodeType="withEffect">
+                            <p:stCondLst>
+                              <p:cond delay="0"/>
+                            </p:stCondLst>
+                            <p:childTnLst>
+                              <p:set>
+                                <p:cBhvr>
+                                  <p:cTn id="25" dur="1" fill="hold">
+                                    <p:stCondLst>
+                                      <p:cond delay="0"/>
+                                    </p:stCondLst>
+                                  </p:cTn>
+                                  <p:tgtEl>
+                                    <p:spTgt spid="11"/>
+                                  </p:tgtEl>
+                                  <p:attrNameLst>
+                                    <p:attrName>style.visibility</p:attrName>
+                                  </p:attrNameLst>
+                                </p:cBhvr>
+                                <p:to>
+                                  <p:strVal val="visible"/>
+                                </p:to>
+                              </p:set>
+                              <p:animEffect transition="in" filter="fade">
+                                <p:cBhvr>
+                                  <p:cTn id="26" dur="450"/>
+                                  <p:tgtEl>
+                                    <p:spTgt spid="11"/>
+                                  </p:tgtEl>
+                                </p:cBhvr>
+                              </p:animEffect>
+                            </p:childTnLst>
+                          </p:cTn>
+                        </p:par>
+                      </p:childTnLst>
+                    </p:cTn>
+                  </p:par>
+                  <p:par>
+                    <p:cTn id="27" fill="hold">
+                      <p:stCondLst>
+                        <p:cond delay="1080"/>
+                      </p:stCondLst>
+                      <p:childTnLst>
+                        <p:par>
+                          <p:cTn id="28" presetID="10" presetClass="entr" presetSubtype="0" fill="hold" nodeType="withEffect">
+                            <p:stCondLst>
+                              <p:cond delay="0"/>
+                            </p:stCondLst>
+                            <p:childTnLst>
+                              <p:set>
+                                <p:cBhvr>
+                                  <p:cTn id="29" dur="1" fill="hold">
+                                    <p:stCondLst>
+                                      <p:cond delay="0"/>
+                                    </p:stCondLst>
+                                  </p:cTn>
+                                  <p:tgtEl>
+                                    <p:spTgt spid="12"/>
+                                  </p:tgtEl>
+                                  <p:attrNameLst>
+                                    <p:attrName>style.visibility</p:attrName>
+                                  </p:attrNameLst>
+                                </p:cBhvr>
+                                <p:to>
+                                  <p:strVal val="visible"/>
+                                </p:to>
+                              </p:set>
+                              <p:animEffect transition="in" filter="fade">
+                                <p:cBhvr>
+                                  <p:cTn id="30" dur="450"/>
+                                  <p:tgtEl>
+                                    <p:spTgt spid="12"/>
+                                  </p:tgtEl>
+                                </p:cBhvr>
+                              </p:animEffect>
+                            </p:childTnLst>
+                          </p:cTn>
+                        </p:par>
+                      </p:childTnLst>
+                    </p:cTn>
+                  </p:par>
+                  <p:par>
+                    <p:cTn id="31" fill="hold">
+                      <p:stCondLst>
+                        <p:cond delay="1260"/>
+                      </p:stCondLst>
+                      <p:childTnLst>
+                        <p:par>
+                          <p:cTn id="32" presetID="10" presetClass="entr" presetSubtype="0" fill="hold" nodeType="withEffect">
+                            <p:stCondLst>
+                              <p:cond delay="0"/>
+                            </p:stCondLst>
+                            <p:childTnLst>
+                              <p:set>
+                                <p:cBhvr>
+                                  <p:cTn id="33" dur="1" fill="hold">
+                                    <p:stCondLst>
+                                      <p:cond delay="0"/>
+                                    </p:stCondLst>
+                                  </p:cTn>
+                                  <p:tgtEl>
+                                    <p:spTgt spid="13"/>
+                                  </p:tgtEl>
+                                  <p:attrNameLst>
+                                    <p:attrName>style.visibility</p:attrName>
+                                  </p:attrNameLst>
+                                </p:cBhvr>
+                                <p:to>
+                                  <p:strVal val="visible"/>
+                                </p:to>
+                              </p:set>
+                              <p:animEffect transition="in" filter="fade">
+                                <p:cBhvr>
+                                  <p:cTn id="34" dur="450"/>
+                                  <p:tgtEl>
+                                    <p:spTgt spid="13"/>
+                                  </p:tgtEl>
+                                </p:cBhvr>
+                              </p:animEffect>
+                            </p:childTnLst>
+                          </p:cTn>
+                        </p:par>
+                      </p:childTnLst>
+                    </p:cTn>
+                  </p:par>
+                </p:childTnLst>
+              </p:cTn>
+              <p:prevCondLst>
+                <p:cond evt="onPrev" delay="0">
+                  <p:tgtEl>
+                    <p:sldTgt/>
+                  </p:tgtEl>
+                </p:cond>
+              </p:prevCondLst>
+              <p:nextCondLst>
+                <p:cond evt="onNext" delay="0">
+                  <p:tgtEl>
+                    <p:sldTgt/>
+                  </p:tgtEl>
+                </p:cond>
+              </p:nextCondLst>
+            </p:seq>
+          </p:childTnLst>
+        </p:cTn>
+      </p:par>
+    </p:tnLst>
+  </p:timing>
 </p:sld>
 </file>
 
@@ -6116,6 +8688,300 @@
   <p:transition spd="med">
     <p:fade/>
   </p:transition>
+  <p:timing>
+    <p:tnLst>
+      <p:par>
+        <p:cTn id="1" dur="indefinite" restart="never" nodeType="tmRoot">
+          <p:childTnLst>
+            <p:seq concurrent="1" nextAc="seek">
+              <p:cTn id="2" dur="indefinite" nodeType="mainSeq">
+                <p:childTnLst>
+                  <p:par>
+                    <p:cTn id="3" fill="hold">
+                      <p:stCondLst>
+                        <p:cond delay="0"/>
+                      </p:stCondLst>
+                      <p:childTnLst>
+                        <p:par>
+                          <p:cTn id="4" presetID="10" presetClass="entr" presetSubtype="0" fill="hold" nodeType="withEffect">
+                            <p:stCondLst>
+                              <p:cond delay="0"/>
+                            </p:stCondLst>
+                            <p:childTnLst>
+                              <p:set>
+                                <p:cBhvr>
+                                  <p:cTn id="5" dur="1" fill="hold">
+                                    <p:stCondLst>
+                                      <p:cond delay="0"/>
+                                    </p:stCondLst>
+                                  </p:cTn>
+                                  <p:tgtEl>
+                                    <p:spTgt spid="6"/>
+                                  </p:tgtEl>
+                                  <p:attrNameLst>
+                                    <p:attrName>style.visibility</p:attrName>
+                                  </p:attrNameLst>
+                                </p:cBhvr>
+                                <p:to>
+                                  <p:strVal val="visible"/>
+                                </p:to>
+                              </p:set>
+                              <p:animEffect transition="in" filter="fade">
+                                <p:cBhvr>
+                                  <p:cTn id="6" dur="450"/>
+                                  <p:tgtEl>
+                                    <p:spTgt spid="6"/>
+                                  </p:tgtEl>
+                                </p:cBhvr>
+                              </p:animEffect>
+                            </p:childTnLst>
+                          </p:cTn>
+                        </p:par>
+                      </p:childTnLst>
+                    </p:cTn>
+                  </p:par>
+                  <p:par>
+                    <p:cTn id="7" fill="hold">
+                      <p:stCondLst>
+                        <p:cond delay="180"/>
+                      </p:stCondLst>
+                      <p:childTnLst>
+                        <p:par>
+                          <p:cTn id="8" presetID="10" presetClass="entr" presetSubtype="0" fill="hold" nodeType="withEffect">
+                            <p:stCondLst>
+                              <p:cond delay="0"/>
+                            </p:stCondLst>
+                            <p:childTnLst>
+                              <p:set>
+                                <p:cBhvr>
+                                  <p:cTn id="9" dur="1" fill="hold">
+                                    <p:stCondLst>
+                                      <p:cond delay="0"/>
+                                    </p:stCondLst>
+                                  </p:cTn>
+                                  <p:tgtEl>
+                                    <p:spTgt spid="7"/>
+                                  </p:tgtEl>
+                                  <p:attrNameLst>
+                                    <p:attrName>style.visibility</p:attrName>
+                                  </p:attrNameLst>
+                                </p:cBhvr>
+                                <p:to>
+                                  <p:strVal val="visible"/>
+                                </p:to>
+                              </p:set>
+                              <p:animEffect transition="in" filter="fade">
+                                <p:cBhvr>
+                                  <p:cTn id="10" dur="450"/>
+                                  <p:tgtEl>
+                                    <p:spTgt spid="7"/>
+                                  </p:tgtEl>
+                                </p:cBhvr>
+                              </p:animEffect>
+                            </p:childTnLst>
+                          </p:cTn>
+                        </p:par>
+                      </p:childTnLst>
+                    </p:cTn>
+                  </p:par>
+                  <p:par>
+                    <p:cTn id="11" fill="hold">
+                      <p:stCondLst>
+                        <p:cond delay="360"/>
+                      </p:stCondLst>
+                      <p:childTnLst>
+                        <p:par>
+                          <p:cTn id="12" presetID="10" presetClass="entr" presetSubtype="0" fill="hold" nodeType="withEffect">
+                            <p:stCondLst>
+                              <p:cond delay="0"/>
+                            </p:stCondLst>
+                            <p:childTnLst>
+                              <p:set>
+                                <p:cBhvr>
+                                  <p:cTn id="13" dur="1" fill="hold">
+                                    <p:stCondLst>
+                                      <p:cond delay="0"/>
+                                    </p:stCondLst>
+                                  </p:cTn>
+                                  <p:tgtEl>
+                                    <p:spTgt spid="8"/>
+                                  </p:tgtEl>
+                                  <p:attrNameLst>
+                                    <p:attrName>style.visibility</p:attrName>
+                                  </p:attrNameLst>
+                                </p:cBhvr>
+                                <p:to>
+                                  <p:strVal val="visible"/>
+                                </p:to>
+                              </p:set>
+                              <p:animEffect transition="in" filter="fade">
+                                <p:cBhvr>
+                                  <p:cTn id="14" dur="450"/>
+                                  <p:tgtEl>
+                                    <p:spTgt spid="8"/>
+                                  </p:tgtEl>
+                                </p:cBhvr>
+                              </p:animEffect>
+                            </p:childTnLst>
+                          </p:cTn>
+                        </p:par>
+                      </p:childTnLst>
+                    </p:cTn>
+                  </p:par>
+                  <p:par>
+                    <p:cTn id="15" fill="hold">
+                      <p:stCondLst>
+                        <p:cond delay="540"/>
+                      </p:stCondLst>
+                      <p:childTnLst>
+                        <p:par>
+                          <p:cTn id="16" presetID="10" presetClass="entr" presetSubtype="0" fill="hold" nodeType="withEffect">
+                            <p:stCondLst>
+                              <p:cond delay="0"/>
+                            </p:stCondLst>
+                            <p:childTnLst>
+                              <p:set>
+                                <p:cBhvr>
+                                  <p:cTn id="17" dur="1" fill="hold">
+                                    <p:stCondLst>
+                                      <p:cond delay="0"/>
+                                    </p:stCondLst>
+                                  </p:cTn>
+                                  <p:tgtEl>
+                                    <p:spTgt spid="9"/>
+                                  </p:tgtEl>
+                                  <p:attrNameLst>
+                                    <p:attrName>style.visibility</p:attrName>
+                                  </p:attrNameLst>
+                                </p:cBhvr>
+                                <p:to>
+                                  <p:strVal val="visible"/>
+                                </p:to>
+                              </p:set>
+                              <p:animEffect transition="in" filter="fade">
+                                <p:cBhvr>
+                                  <p:cTn id="18" dur="450"/>
+                                  <p:tgtEl>
+                                    <p:spTgt spid="9"/>
+                                  </p:tgtEl>
+                                </p:cBhvr>
+                              </p:animEffect>
+                            </p:childTnLst>
+                          </p:cTn>
+                        </p:par>
+                      </p:childTnLst>
+                    </p:cTn>
+                  </p:par>
+                  <p:par>
+                    <p:cTn id="19" fill="hold">
+                      <p:stCondLst>
+                        <p:cond delay="720"/>
+                      </p:stCondLst>
+                      <p:childTnLst>
+                        <p:par>
+                          <p:cTn id="20" presetID="10" presetClass="entr" presetSubtype="0" fill="hold" nodeType="withEffect">
+                            <p:stCondLst>
+                              <p:cond delay="0"/>
+                            </p:stCondLst>
+                            <p:childTnLst>
+                              <p:set>
+                                <p:cBhvr>
+                                  <p:cTn id="21" dur="1" fill="hold">
+                                    <p:stCondLst>
+                                      <p:cond delay="0"/>
+                                    </p:stCondLst>
+                                  </p:cTn>
+                                  <p:tgtEl>
+                                    <p:spTgt spid="10"/>
+                                  </p:tgtEl>
+                                  <p:attrNameLst>
+                                    <p:attrName>style.visibility</p:attrName>
+                                  </p:attrNameLst>
+                                </p:cBhvr>
+                                <p:to>
+                                  <p:strVal val="visible"/>
+                                </p:to>
+                              </p:set>
+                              <p:animEffect transition="in" filter="fade">
+                                <p:cBhvr>
+                                  <p:cTn id="22" dur="450"/>
+                                  <p:tgtEl>
+                                    <p:spTgt spid="10"/>
+                                  </p:tgtEl>
+                                </p:cBhvr>
+                              </p:animEffect>
+                            </p:childTnLst>
+                          </p:cTn>
+                        </p:par>
+                      </p:childTnLst>
+                    </p:cTn>
+                  </p:par>
+                  <p:par>
+                    <p:cTn id="23" fill="hold">
+                      <p:stCondLst>
+                        <p:cond delay="900"/>
+                      </p:stCondLst>
+                      <p:childTnLst>
+                        <p:par>
+                          <p:cTn id="24" presetID="10" presetClass="entr" presetSubtype="0" fill="hold" nodeType="withEffect">
+                            <p:stCondLst>
+                              <p:cond delay="0"/>
+                            </p:stCondLst>
+                            <p:childTnLst>
+                              <p:set>
+                                <p:cBhvr>
+                                  <p:cTn id="25" dur="1" fill="hold">
+                                    <p:stCondLst>
+                                      <p:cond delay="0"/>
+                                    </p:stCondLst>
+                                  </p:cTn>
+                                  <p:tgtEl>
+                                    <p:spTgt spid="11"/>
+                                  </p:tgtEl>
+                                  <p:attrNameLst>
+                                    <p:attrName>style.visibility</p:attrName>
+                                  </p:attrNameLst>
+                                </p:cBhvr>
+                                <p:to>
+                                  <p:strVal val="visible"/>
+                                </p:to>
+                              </p:set>
+                              <p:animEffect transition="in" filter="fade">
+                                <p:cBhvr>
+                                  <p:cTn id="26" dur="450"/>
+                                  <p:tgtEl>
+                                    <p:spTgt spid="11"/>
+                                  </p:tgtEl>
+                                </p:cBhvr>
+                              </p:animEffect>
+                            </p:childTnLst>
+                          </p:cTn>
+                        </p:par>
+                      </p:childTnLst>
+                    </p:cTn>
+                  </p:par>
+                </p:childTnLst>
+              </p:cTn>
+              <p:prevCondLst>
+                <p:cond evt="onPrev" delay="0">
+                  <p:tgtEl>
+                    <p:sldTgt/>
+                  </p:tgtEl>
+                </p:cond>
+              </p:prevCondLst>
+              <p:nextCondLst>
+                <p:cond evt="onNext" delay="0">
+                  <p:tgtEl>
+                    <p:sldTgt/>
+                  </p:tgtEl>
+                </p:cond>
+              </p:nextCondLst>
+            </p:seq>
+          </p:childTnLst>
+        </p:cTn>
+      </p:par>
+    </p:tnLst>
+  </p:timing>
 </p:sld>
 </file>
 
@@ -6974,6 +9840,300 @@
   <p:transition spd="med">
     <p:fade/>
   </p:transition>
+  <p:timing>
+    <p:tnLst>
+      <p:par>
+        <p:cTn id="1" dur="indefinite" restart="never" nodeType="tmRoot">
+          <p:childTnLst>
+            <p:seq concurrent="1" nextAc="seek">
+              <p:cTn id="2" dur="indefinite" nodeType="mainSeq">
+                <p:childTnLst>
+                  <p:par>
+                    <p:cTn id="3" fill="hold">
+                      <p:stCondLst>
+                        <p:cond delay="0"/>
+                      </p:stCondLst>
+                      <p:childTnLst>
+                        <p:par>
+                          <p:cTn id="4" presetID="10" presetClass="entr" presetSubtype="0" fill="hold" nodeType="withEffect">
+                            <p:stCondLst>
+                              <p:cond delay="0"/>
+                            </p:stCondLst>
+                            <p:childTnLst>
+                              <p:set>
+                                <p:cBhvr>
+                                  <p:cTn id="5" dur="1" fill="hold">
+                                    <p:stCondLst>
+                                      <p:cond delay="0"/>
+                                    </p:stCondLst>
+                                  </p:cTn>
+                                  <p:tgtEl>
+                                    <p:spTgt spid="6"/>
+                                  </p:tgtEl>
+                                  <p:attrNameLst>
+                                    <p:attrName>style.visibility</p:attrName>
+                                  </p:attrNameLst>
+                                </p:cBhvr>
+                                <p:to>
+                                  <p:strVal val="visible"/>
+                                </p:to>
+                              </p:set>
+                              <p:animEffect transition="in" filter="fade">
+                                <p:cBhvr>
+                                  <p:cTn id="6" dur="450"/>
+                                  <p:tgtEl>
+                                    <p:spTgt spid="6"/>
+                                  </p:tgtEl>
+                                </p:cBhvr>
+                              </p:animEffect>
+                            </p:childTnLst>
+                          </p:cTn>
+                        </p:par>
+                      </p:childTnLst>
+                    </p:cTn>
+                  </p:par>
+                  <p:par>
+                    <p:cTn id="7" fill="hold">
+                      <p:stCondLst>
+                        <p:cond delay="180"/>
+                      </p:stCondLst>
+                      <p:childTnLst>
+                        <p:par>
+                          <p:cTn id="8" presetID="10" presetClass="entr" presetSubtype="0" fill="hold" nodeType="withEffect">
+                            <p:stCondLst>
+                              <p:cond delay="0"/>
+                            </p:stCondLst>
+                            <p:childTnLst>
+                              <p:set>
+                                <p:cBhvr>
+                                  <p:cTn id="9" dur="1" fill="hold">
+                                    <p:stCondLst>
+                                      <p:cond delay="0"/>
+                                    </p:stCondLst>
+                                  </p:cTn>
+                                  <p:tgtEl>
+                                    <p:spTgt spid="7"/>
+                                  </p:tgtEl>
+                                  <p:attrNameLst>
+                                    <p:attrName>style.visibility</p:attrName>
+                                  </p:attrNameLst>
+                                </p:cBhvr>
+                                <p:to>
+                                  <p:strVal val="visible"/>
+                                </p:to>
+                              </p:set>
+                              <p:animEffect transition="in" filter="fade">
+                                <p:cBhvr>
+                                  <p:cTn id="10" dur="450"/>
+                                  <p:tgtEl>
+                                    <p:spTgt spid="7"/>
+                                  </p:tgtEl>
+                                </p:cBhvr>
+                              </p:animEffect>
+                            </p:childTnLst>
+                          </p:cTn>
+                        </p:par>
+                      </p:childTnLst>
+                    </p:cTn>
+                  </p:par>
+                  <p:par>
+                    <p:cTn id="11" fill="hold">
+                      <p:stCondLst>
+                        <p:cond delay="360"/>
+                      </p:stCondLst>
+                      <p:childTnLst>
+                        <p:par>
+                          <p:cTn id="12" presetID="10" presetClass="entr" presetSubtype="0" fill="hold" nodeType="withEffect">
+                            <p:stCondLst>
+                              <p:cond delay="0"/>
+                            </p:stCondLst>
+                            <p:childTnLst>
+                              <p:set>
+                                <p:cBhvr>
+                                  <p:cTn id="13" dur="1" fill="hold">
+                                    <p:stCondLst>
+                                      <p:cond delay="0"/>
+                                    </p:stCondLst>
+                                  </p:cTn>
+                                  <p:tgtEl>
+                                    <p:spTgt spid="8"/>
+                                  </p:tgtEl>
+                                  <p:attrNameLst>
+                                    <p:attrName>style.visibility</p:attrName>
+                                  </p:attrNameLst>
+                                </p:cBhvr>
+                                <p:to>
+                                  <p:strVal val="visible"/>
+                                </p:to>
+                              </p:set>
+                              <p:animEffect transition="in" filter="fade">
+                                <p:cBhvr>
+                                  <p:cTn id="14" dur="450"/>
+                                  <p:tgtEl>
+                                    <p:spTgt spid="8"/>
+                                  </p:tgtEl>
+                                </p:cBhvr>
+                              </p:animEffect>
+                            </p:childTnLst>
+                          </p:cTn>
+                        </p:par>
+                      </p:childTnLst>
+                    </p:cTn>
+                  </p:par>
+                  <p:par>
+                    <p:cTn id="15" fill="hold">
+                      <p:stCondLst>
+                        <p:cond delay="540"/>
+                      </p:stCondLst>
+                      <p:childTnLst>
+                        <p:par>
+                          <p:cTn id="16" presetID="10" presetClass="entr" presetSubtype="0" fill="hold" nodeType="withEffect">
+                            <p:stCondLst>
+                              <p:cond delay="0"/>
+                            </p:stCondLst>
+                            <p:childTnLst>
+                              <p:set>
+                                <p:cBhvr>
+                                  <p:cTn id="17" dur="1" fill="hold">
+                                    <p:stCondLst>
+                                      <p:cond delay="0"/>
+                                    </p:stCondLst>
+                                  </p:cTn>
+                                  <p:tgtEl>
+                                    <p:spTgt spid="9"/>
+                                  </p:tgtEl>
+                                  <p:attrNameLst>
+                                    <p:attrName>style.visibility</p:attrName>
+                                  </p:attrNameLst>
+                                </p:cBhvr>
+                                <p:to>
+                                  <p:strVal val="visible"/>
+                                </p:to>
+                              </p:set>
+                              <p:animEffect transition="in" filter="fade">
+                                <p:cBhvr>
+                                  <p:cTn id="18" dur="450"/>
+                                  <p:tgtEl>
+                                    <p:spTgt spid="9"/>
+                                  </p:tgtEl>
+                                </p:cBhvr>
+                              </p:animEffect>
+                            </p:childTnLst>
+                          </p:cTn>
+                        </p:par>
+                      </p:childTnLst>
+                    </p:cTn>
+                  </p:par>
+                  <p:par>
+                    <p:cTn id="19" fill="hold">
+                      <p:stCondLst>
+                        <p:cond delay="720"/>
+                      </p:stCondLst>
+                      <p:childTnLst>
+                        <p:par>
+                          <p:cTn id="20" presetID="10" presetClass="entr" presetSubtype="0" fill="hold" nodeType="withEffect">
+                            <p:stCondLst>
+                              <p:cond delay="0"/>
+                            </p:stCondLst>
+                            <p:childTnLst>
+                              <p:set>
+                                <p:cBhvr>
+                                  <p:cTn id="21" dur="1" fill="hold">
+                                    <p:stCondLst>
+                                      <p:cond delay="0"/>
+                                    </p:stCondLst>
+                                  </p:cTn>
+                                  <p:tgtEl>
+                                    <p:spTgt spid="10"/>
+                                  </p:tgtEl>
+                                  <p:attrNameLst>
+                                    <p:attrName>style.visibility</p:attrName>
+                                  </p:attrNameLst>
+                                </p:cBhvr>
+                                <p:to>
+                                  <p:strVal val="visible"/>
+                                </p:to>
+                              </p:set>
+                              <p:animEffect transition="in" filter="fade">
+                                <p:cBhvr>
+                                  <p:cTn id="22" dur="450"/>
+                                  <p:tgtEl>
+                                    <p:spTgt spid="10"/>
+                                  </p:tgtEl>
+                                </p:cBhvr>
+                              </p:animEffect>
+                            </p:childTnLst>
+                          </p:cTn>
+                        </p:par>
+                      </p:childTnLst>
+                    </p:cTn>
+                  </p:par>
+                  <p:par>
+                    <p:cTn id="23" fill="hold">
+                      <p:stCondLst>
+                        <p:cond delay="900"/>
+                      </p:stCondLst>
+                      <p:childTnLst>
+                        <p:par>
+                          <p:cTn id="24" presetID="10" presetClass="entr" presetSubtype="0" fill="hold" nodeType="withEffect">
+                            <p:stCondLst>
+                              <p:cond delay="0"/>
+                            </p:stCondLst>
+                            <p:childTnLst>
+                              <p:set>
+                                <p:cBhvr>
+                                  <p:cTn id="25" dur="1" fill="hold">
+                                    <p:stCondLst>
+                                      <p:cond delay="0"/>
+                                    </p:stCondLst>
+                                  </p:cTn>
+                                  <p:tgtEl>
+                                    <p:spTgt spid="11"/>
+                                  </p:tgtEl>
+                                  <p:attrNameLst>
+                                    <p:attrName>style.visibility</p:attrName>
+                                  </p:attrNameLst>
+                                </p:cBhvr>
+                                <p:to>
+                                  <p:strVal val="visible"/>
+                                </p:to>
+                              </p:set>
+                              <p:animEffect transition="in" filter="fade">
+                                <p:cBhvr>
+                                  <p:cTn id="26" dur="450"/>
+                                  <p:tgtEl>
+                                    <p:spTgt spid="11"/>
+                                  </p:tgtEl>
+                                </p:cBhvr>
+                              </p:animEffect>
+                            </p:childTnLst>
+                          </p:cTn>
+                        </p:par>
+                      </p:childTnLst>
+                    </p:cTn>
+                  </p:par>
+                </p:childTnLst>
+              </p:cTn>
+              <p:prevCondLst>
+                <p:cond evt="onPrev" delay="0">
+                  <p:tgtEl>
+                    <p:sldTgt/>
+                  </p:tgtEl>
+                </p:cond>
+              </p:prevCondLst>
+              <p:nextCondLst>
+                <p:cond evt="onNext" delay="0">
+                  <p:tgtEl>
+                    <p:sldTgt/>
+                  </p:tgtEl>
+                </p:cond>
+              </p:nextCondLst>
+            </p:seq>
+          </p:childTnLst>
+        </p:cTn>
+      </p:par>
+    </p:tnLst>
+  </p:timing>
 </p:sld>
 </file>
 

</xml_diff>